<commit_message>
Studio workshop: train for 30 steps, start training first
Measured on a Radeon 8065S (Ryzen AI Max+, native Windows Studio): 30 steps
take ~4.7 min and score 29 of 30 held-out tickets exactly right; 60 steps
take 9.3 min for 30 of 30. The loss is flat by step 15-25.

- Notebook reordered so attendees start training in Studio first and walk
  through the data while it runs; Max Steps 30 throughout
- Screenshots 05-07 retaken from a 30-step run; deck slides 15-16 and the
  PDF updated, with the 8065S numbers (97% vs 63% schema prompt)
- Executed notebook re-run against a 30-step adapter (97% vs 70%)
- "Bigger model" suggestion now Qwen3.5-9B, not Gemma (Studio's <bos> issue)
</commit_message>
<xml_diff>
--- a/docs/AMD-Unsloth-Studio-Fine-tuning.pptx
+++ b/docs/AMD-Unsloth-Studio-Fine-tuning.pptx
@@ -24028,7 +24028,7 @@
                 </a:solidFill>
                 <a:latin typeface="Klavika Bold"/>
               </a:rPr>
-              <a:t>Set 60 steps, then Start Training</a:t>
+              <a:t>Set 30 steps, then Start Training</a:t>
             </a:r>
           </a:p>
         </p:txBody>
@@ -24434,7 +24434,7 @@
                 </a:solidFill>
                 <a:latin typeface="Klavika Regular"/>
               </a:rPr>
-              <a:t>Sixty SFT steps on a Radeon GPU, and the model speaks your schema.</a:t>
+              <a:t>Thirty SFT steps on a Radeon GPU, and the model speaks your schema.</a:t>
             </a:r>
           </a:p>
         </p:txBody>
@@ -24487,7 +24487,7 @@
                 </a:solidFill>
                 <a:latin typeface="Klavika Bold"/>
               </a:rPr>
-              <a:t>DEMO: 60 STEPS</a:t>
+              <a:t>DEMO: 30 STEPS</a:t>
             </a:r>
           </a:p>
         </p:txBody>
@@ -24921,7 +24921,7 @@
                 </a:solidFill>
                 <a:latin typeface="Klavika Regular"/>
               </a:rPr>
-              <a:t>Held-out tickets exactly right: 70% with a schema prompt, 100% fine-tuned</a:t>
+              <a:t>Held-out tickets exactly right on a Ryzen AI Max: 63% with a schema prompt, 97% fine-tuned</a:t>
             </a:r>
           </a:p>
         </p:txBody>

</xml_diff>

<commit_message>
Studio workshop: localhost setup, Windows GPU check, plainer wording
The workshop now runs entirely on the attendee's machine (Studio at
localhost:8890, notebook at localhost:8888, native Windows on a Ryzen AI
Max+), so the materials match that:

- Slides 2, 13, 18: localhost access instead of the cloud portal
- Slide 14: hipInfo and Task Manager instead of rocminfo / rocm-smi,
  which do not exist on Windows; Studio's GPU Monitor shows only memory
  there, so its 0% utilisation is not used as a "training stopped" sign
- Screenshots 02 and 04-07 retaken on the Radeon 8065S
- Notebook: no install step, uploads from the local data folder, Thinking
  off by default, measured 8065S timings and scores
- Slide and notebook text rewritten in plainer language
- Executed notebook copy is now the native 8065S run (97% vs 63%)
</commit_message>
<xml_diff>
--- a/docs/AMD-Unsloth-Studio-Fine-tuning.pptx
+++ b/docs/AMD-Unsloth-Studio-Fine-tuning.pptx
@@ -20625,7 +20625,7 @@
                 </a:solidFill>
                 <a:latin typeface="Klavika Regular"/>
               </a:rPr>
-              <a:t> puts the whole loop in a browser tab: pick a model, upload data, train, chat, export. No code.</a:t>
+              <a:t> runs the whole process in your browser, from picking a model to exporting the result, without writing code.</a:t>
             </a:r>
           </a:p>
         </p:txBody>
@@ -20820,7 +20820,7 @@
                 </a:solidFill>
                 <a:latin typeface="Klavika Regular"/>
               </a:rPr>
-              <a:t>Messy text in, </a:t>
+              <a:t>Turn a customer's message into a </a:t>
             </a:r>
             <a:r>
               <a:rPr sz="1700" b="1" dirty="0">
@@ -20829,7 +20829,7 @@
                 </a:solidFill>
                 <a:latin typeface="Klavika Bold"/>
               </a:rPr>
-              <a:t>structured data</a:t>
+              <a:t>ticket record</a:t>
             </a:r>
             <a:r>
               <a:rPr sz="1700" b="0" dirty="0">
@@ -20838,7 +20838,7 @@
                 </a:solidFill>
                 <a:latin typeface="Klavika Regular"/>
               </a:rPr>
-              <a:t> out.</a:t>
+              <a:t>.</a:t>
             </a:r>
           </a:p>
           <a:p>
@@ -20860,7 +20860,7 @@
                 </a:solidFill>
                 <a:latin typeface="Klavika Regular"/>
               </a:rPr>
-              <a:t>Customers write however they like. The ticket system needs the same seven fields, in the same format, every time.</a:t>
+              <a:t>Customers write in their own words. The ticket system needs the same seven fields in the same format every time.</a:t>
             </a:r>
           </a:p>
         </p:txBody>
@@ -20993,7 +20993,7 @@
                 </a:solidFill>
                 <a:latin typeface="Klavika Bold"/>
               </a:rPr>
-              <a:t>Verifiable</a:t>
+              <a:t>Easy to check</a:t>
             </a:r>
           </a:p>
         </p:txBody>
@@ -21035,7 +21035,7 @@
                 </a:solidFill>
                 <a:latin typeface="Klavika Regular"/>
               </a:rPr>
-              <a:t>Every field is right or wrong. Score it with code.</a:t>
+              <a:t>Each field is either right or wrong, so a script can grade it.</a:t>
             </a:r>
           </a:p>
         </p:txBody>
@@ -21168,7 +21168,7 @@
                 </a:solidFill>
                 <a:latin typeface="Klavika Bold"/>
               </a:rPr>
-              <a:t>Teaches format</a:t>
+              <a:t>Learns the format</a:t>
             </a:r>
           </a:p>
         </p:txBody>
@@ -21210,7 +21210,7 @@
                 </a:solidFill>
                 <a:latin typeface="Klavika Regular"/>
               </a:rPr>
-              <a:t>One-line prompt in, exact schema out. No rules in the prompt.</a:t>
+              <a:t>The prompt is one line. The fields and rules come from the examples.</a:t>
             </a:r>
           </a:p>
         </p:txBody>
@@ -21343,7 +21343,7 @@
                 </a:solidFill>
                 <a:latin typeface="Klavika Bold"/>
               </a:rPr>
-              <a:t>Real judgment</a:t>
+              <a:t>Needs some judgment</a:t>
             </a:r>
           </a:p>
         </p:txBody>
@@ -21385,7 +21385,7 @@
                 </a:solidFill>
                 <a:latin typeface="Klavika Regular"/>
               </a:rPr>
-              <a:t>“Not the model I ordered” means wrong_item. Dates and amounts get normalized.</a:t>
+              <a:t>“Not the model I ordered” has to become wrong_item, and dates and prices a standard format.</a:t>
             </a:r>
           </a:p>
         </p:txBody>
@@ -21496,7 +21496,7 @@
                 </a:solidFill>
                 <a:latin typeface="Klavika Regular"/>
               </a:rPr>
-              <a:t>A held-out message and the fine-tuned model’s answer</a:t>
+              <a:t>A test message the model never saw, and its answer after fine-tuning</a:t>
             </a:r>
           </a:p>
         </p:txBody>
@@ -21559,7 +21559,7 @@
                 </a:solidFill>
                 <a:latin typeface="Klavika Bold"/>
               </a:rPr>
-              <a:t>AMD Unsloth fine-tuning workshop</a:t>
+              <a:t>Getting started</a:t>
             </a:r>
           </a:p>
         </p:txBody>
@@ -21745,7 +21745,7 @@
                 </a:solidFill>
                 <a:latin typeface="Klavika Bold"/>
               </a:rPr>
-              <a:t>Open the portal</a:t>
+              <a:t>Open Unsloth Studio</a:t>
             </a:r>
           </a:p>
         </p:txBody>
@@ -21787,7 +21787,7 @@
                 </a:solidFill>
                 <a:latin typeface="Consolas"/>
               </a:rPr>
-              <a:t>notebooks.amd.com/</a:t>
+              <a:t>localhost:8890</a:t>
             </a:r>
             <a:r>
               <a:rPr sz="2000" b="1" dirty="0" err="1">
@@ -21796,7 +21796,7 @@
                 </a:solidFill>
                 <a:latin typeface="Consolas"/>
               </a:rPr>
-              <a:t>ind</a:t>
+              <a:t/>
             </a:r>
             <a:r>
               <a:rPr sz="2000" b="1" dirty="0">
@@ -21805,7 +21805,7 @@
                 </a:solidFill>
                 <a:latin typeface="Consolas"/>
               </a:rPr>
-              <a:t>-dev</a:t>
+              <a:t/>
             </a:r>
           </a:p>
         </p:txBody>
@@ -21991,7 +21991,7 @@
                 </a:solidFill>
                 <a:latin typeface="Klavika Bold"/>
               </a:rPr>
-              <a:t>Enter the password</a:t>
+              <a:t>Sign in: RadeonUnslothStudio</a:t>
             </a:r>
           </a:p>
         </p:txBody>
@@ -22177,7 +22177,7 @@
                 </a:solidFill>
                 <a:latin typeface="Klavika Bold"/>
               </a:rPr>
-              <a:t>Pick the Unsloth card</a:t>
+              <a:t>Open the notebook</a:t>
             </a:r>
           </a:p>
         </p:txBody>
@@ -22219,7 +22219,7 @@
                 </a:solidFill>
                 <a:latin typeface="Klavika Regular"/>
               </a:rPr>
-              <a:t>Lands you on an AMD Radeon GPU</a:t>
+              <a:t>localhost:8888, in a second tab</a:t>
             </a:r>
           </a:p>
         </p:txBody>
@@ -22278,7 +22278,7 @@
           <p:nvPr/>
         </p:nvPicPr>
         <p:blipFill>
-          <a:blip r:embed="rId4"/>
+          <a:blip r:embed="rId5"/>
           <a:stretch>
             <a:fillRect/>
           </a:stretch>
@@ -22393,7 +22393,7 @@
                 </a:solidFill>
                 <a:latin typeface="Klavika Regular"/>
               </a:rPr>
-              <a:t>Open a terminal inside Jupyter and confirm the GPU is </a:t>
+              <a:t>Before you train, check that the GPU is </a:t>
             </a:r>
             <a:r>
               <a:rPr lang="en-US" sz="1500" b="0" dirty="0">
@@ -22402,7 +22402,7 @@
                 </a:solidFill>
                 <a:latin typeface="Klavika Regular"/>
               </a:rPr>
-              <a:t>available </a:t>
+              <a:t>visible</a:t>
             </a:r>
             <a:r>
               <a:rPr sz="1500" b="0" dirty="0">
@@ -22411,7 +22411,7 @@
                 </a:solidFill>
                 <a:latin typeface="Klavika Regular"/>
               </a:rPr>
-              <a:t>before you train.</a:t>
+              <a:t>.</a:t>
             </a:r>
           </a:p>
         </p:txBody>
@@ -22680,7 +22680,7 @@
                 </a:solidFill>
                 <a:latin typeface="Consolas"/>
               </a:rPr>
-              <a:t>$ </a:t>
+              <a:t>&gt; </a:t>
             </a:r>
             <a:r>
               <a:rPr sz="1400" b="0" dirty="0" err="1">
@@ -22689,7 +22689,7 @@
                 </a:solidFill>
                 <a:latin typeface="Consolas"/>
               </a:rPr>
-              <a:t>rocm-smi</a:t>
+              <a:t>hipInfo</a:t>
             </a:r>
             <a:endParaRPr sz="1400" b="0" dirty="0">
               <a:solidFill>
@@ -22717,7 +22717,7 @@
                 </a:solidFill>
                 <a:latin typeface="Consolas"/>
               </a:rPr>
-              <a:t>$ </a:t>
+              <a:t/>
             </a:r>
             <a:r>
               <a:rPr sz="1400" b="0" dirty="0" err="1">
@@ -22726,7 +22726,7 @@
                 </a:solidFill>
                 <a:latin typeface="Consolas"/>
               </a:rPr>
-              <a:t>rocminfo</a:t>
+              <a:t/>
             </a:r>
             <a:endParaRPr sz="1400" b="0" dirty="0">
               <a:solidFill>
@@ -22865,7 +22865,7 @@
                 </a:solidFill>
                 <a:latin typeface="Consolas"/>
               </a:rPr>
-              <a:t>rocm-smi</a:t>
+              <a:t>hipInfo</a:t>
             </a:r>
           </a:p>
         </p:txBody>
@@ -22910,7 +22910,7 @@
                 </a:solidFill>
                 <a:latin typeface="Klavika Regular"/>
               </a:rPr>
-              <a:t>Live view: temperature, power, clocks, VRAM use</a:t>
+              <a:t>The GPU's name, architecture and memory</a:t>
             </a:r>
           </a:p>
         </p:txBody>
@@ -23043,7 +23043,7 @@
                 </a:solidFill>
                 <a:latin typeface="Consolas"/>
               </a:rPr>
-              <a:t>rocminfo</a:t>
+              <a:t>Task Manager</a:t>
             </a:r>
           </a:p>
         </p:txBody>
@@ -23088,7 +23088,7 @@
                 </a:solidFill>
                 <a:latin typeface="Klavika Regular"/>
               </a:rPr>
-              <a:t>Static view: agents, ROCm version, GPU identity</a:t>
+              <a:t>Performance, then GPU, then the Compute graph for live load</a:t>
             </a:r>
           </a:p>
         </p:txBody>
@@ -23224,7 +23224,7 @@
                 </a:solidFill>
                 <a:latin typeface="Klavika Regular"/>
               </a:rPr>
-              <a:t>GPU busy at 0% while a cell runs? It is not training.</a:t>
+              <a:t>Compute graph flat during a run? Training has stopped.</a:t>
             </a:r>
           </a:p>
         </p:txBody>
@@ -23283,7 +23283,7 @@
           <p:nvPr/>
         </p:nvPicPr>
         <p:blipFill>
-          <a:blip r:embed="rId4"/>
+          <a:blip r:embed="rId6"/>
           <a:stretch>
             <a:fillRect/>
           </a:stretch>
@@ -23352,7 +23352,7 @@
           <p:nvPr/>
         </p:nvPicPr>
         <p:blipFill>
-          <a:blip r:embed="rId5"/>
+          <a:blip r:embed="rId7"/>
           <a:stretch>
             <a:fillRect/>
           </a:stretch>
@@ -23407,7 +23407,7 @@
                 </a:solidFill>
                 <a:latin typeface="Klavika Regular"/>
               </a:rPr>
-              <a:t>rocminfo confirms the ROCm runtime version and every agent the host exposes, GPU and CPU alike.</a:t>
+              <a:t>On Windows, Studio's GPU Monitor shows memory in use (here 11.8 of 116.7 GiB on a Ryzen AI Max+) but not load. Open the terminal in JupyterLab: File, New, Terminal.</a:t>
             </a:r>
           </a:p>
         </p:txBody>
@@ -23512,7 +23512,7 @@
                 </a:solidFill>
                 <a:latin typeface="Klavika Regular"/>
               </a:rPr>
-              <a:t>Four steps on the Train page. The first model load is the slow one.</a:t>
+              <a:t>Everything happens on the Train page. Loading the model the first time takes longest.</a:t>
             </a:r>
           </a:p>
         </p:txBody>
@@ -23645,7 +23645,7 @@
                 </a:solidFill>
                 <a:latin typeface="Klavika Bold"/>
               </a:rPr>
-              <a:t>Pick model and method</a:t>
+              <a:t>Pick the model and method</a:t>
             </a:r>
           </a:p>
         </p:txBody>
@@ -23895,7 +23895,7 @@
                 </a:solidFill>
                 <a:latin typeface="Klavika Regular"/>
               </a:rPr>
-              <a:t>support_tickets_train.jsonl. View dataset should say ChatML</a:t>
+              <a:t>support_tickets_train.jsonl. Check that View dataset shows ChatML</a:t>
             </a:r>
           </a:p>
         </p:txBody>
@@ -24028,7 +24028,7 @@
                 </a:solidFill>
                 <a:latin typeface="Klavika Bold"/>
               </a:rPr>
-              <a:t>Set 30 steps, then Start Training</a:t>
+              <a:t>Set 30 steps and start training</a:t>
             </a:r>
           </a:p>
         </p:txBody>
@@ -24073,7 +24073,7 @@
                 </a:solidFill>
                 <a:latin typeface="Klavika Regular"/>
               </a:rPr>
-              <a:t>Watch the loss chart, and the GPU in </a:t>
+              <a:t>Watch the loss chart, and the GPU in Task Manager</a:t>
             </a:r>
             <a:r>
               <a:rPr sz="1200" b="0">
@@ -24082,7 +24082,7 @@
                 </a:solidFill>
                 <a:latin typeface="Consolas"/>
               </a:rPr>
-              <a:t>rocm-smi</a:t>
+              <a:t/>
             </a:r>
           </a:p>
         </p:txBody>
@@ -24260,7 +24260,7 @@
                 </a:solidFill>
                 <a:latin typeface="Klavika Regular"/>
               </a:rPr>
-              <a:t>Thinking off, then paste a held-out message. Base and fine-tuned answer side by side</a:t>
+              <a:t>Turn Thinking off, paste a test message, and read both answers side by side</a:t>
             </a:r>
           </a:p>
         </p:txBody>
@@ -24434,7 +24434,7 @@
                 </a:solidFill>
                 <a:latin typeface="Klavika Regular"/>
               </a:rPr>
-              <a:t>Thirty SFT steps on a Radeon GPU, and the model speaks your schema.</a:t>
+              <a:t>After 30 training steps, the model answers in the ticket format.</a:t>
             </a:r>
           </a:p>
         </p:txBody>
@@ -24598,7 +24598,7 @@
                 </a:solidFill>
                 <a:latin typeface="Klavika Regular"/>
               </a:rPr>
-              <a:t>Loss and gradient norm per step, straight from Studio</a:t>
+              <a:t>Loss and gradient norm for each step, from Studio</a:t>
             </a:r>
           </a:p>
         </p:txBody>
@@ -24709,7 +24709,7 @@
                 </a:solidFill>
                 <a:latin typeface="Klavika Regular"/>
               </a:rPr>
-              <a:t>Fine-tuned answer to a held-out message, in exactly the schema</a:t>
+              <a:t>The fine-tuned model's answer to a test message</a:t>
             </a:r>
           </a:p>
         </p:txBody>
@@ -24893,7 +24893,7 @@
                 </a:solidFill>
                 <a:latin typeface="Klavika Regular"/>
               </a:rPr>
-              <a:t>Loss drops in the first 15 steps, then flattens</a:t>
+              <a:t>Loss falls over the first 15 steps, then levels off</a:t>
             </a:r>
           </a:p>
           <a:p>
@@ -24921,7 +24921,7 @@
                 </a:solidFill>
                 <a:latin typeface="Klavika Regular"/>
               </a:rPr>
-              <a:t>Held-out tickets exactly right on a Ryzen AI Max: 63% with a schema prompt, 97% fine-tuned</a:t>
+              <a:t>On a Ryzen AI Max+, 29 of 30 test tickets came out exactly right, against 19 of 30 with a detailed prompt</a:t>
             </a:r>
           </a:p>
         </p:txBody>
@@ -25418,7 +25418,7 @@
                 </a:solidFill>
                 <a:latin typeface="Klavika Regular"/>
               </a:rPr>
-              <a:t>View dataset should say ChatML. Upload the .jsonl from data/ as is.</a:t>
+              <a:t>Upload the .jsonl from data/ unchanged. View dataset should show ChatML.</a:t>
             </a:r>
           </a:p>
         </p:txBody>
@@ -25726,7 +25726,7 @@
                 </a:solidFill>
                 <a:latin typeface="Klavika Bold"/>
               </a:rPr>
-              <a:t>Fine-tuned answers ramble</a:t>
+              <a:t>Answers run on past the JSON</a:t>
             </a:r>
           </a:p>
         </p:txBody>
@@ -25768,7 +25768,7 @@
                 </a:solidFill>
                 <a:latin typeface="Klavika Regular"/>
               </a:rPr>
-              <a:t>Turn Thinking off in Chat. Still rambling? Train more steps.</a:t>
+              <a:t>Turn Thinking off in Chat. If it still happens, train for more steps.</a:t>
             </a:r>
           </a:p>
         </p:txBody>
@@ -25943,7 +25943,7 @@
                 </a:solidFill>
                 <a:latin typeface="Klavika Regular"/>
               </a:rPr>
-              <a:t>Read the error in Current Run. A mismatched Triton install is a common cause.</a:t>
+              <a:t>Check the error on the Current Run page. A mismatched Triton install is a common cause.</a:t>
             </a:r>
           </a:p>
         </p:txBody>
@@ -26076,7 +26076,7 @@
                 </a:solidFill>
                 <a:latin typeface="Klavika Bold"/>
               </a:rPr>
-              <a:t>Need a next experiment?</a:t>
+              <a:t>What to try next</a:t>
             </a:r>
           </a:p>
         </p:txBody>
@@ -26118,7 +26118,7 @@
                 </a:solidFill>
                 <a:latin typeface="Klavika Regular"/>
               </a:rPr>
-              <a:t>Your own JSONL with a messages column, or a bigger model like Qwen3.5-9B.</a:t>
+              <a:t>Your own data in the same format, or a larger model such as Qwen3.5-9B.</a:t>
             </a:r>
           </a:p>
         </p:txBody>
@@ -27266,7 +27266,7 @@
                 </a:solidFill>
                 <a:latin typeface="Klavika Regular"/>
               </a:rPr>
-              <a:t>The model we fine-tune</a:t>
+              <a:t>The model used today</a:t>
             </a:r>
           </a:p>
         </p:txBody>
@@ -27399,7 +27399,7 @@
                 </a:solidFill>
                 <a:latin typeface="Klavika Bold"/>
               </a:rPr>
-              <a:t>Workshop notebook</a:t>
+              <a:t>This workshop</a:t>
             </a:r>
           </a:p>
         </p:txBody>
@@ -27441,7 +27441,7 @@
                 </a:solidFill>
                 <a:latin typeface="Consolas"/>
               </a:rPr>
-              <a:t>notebooks.amd.com/ind-dev</a:t>
+              <a:t>localhost:8890 and :8888</a:t>
             </a:r>
           </a:p>
         </p:txBody>
@@ -27483,7 +27483,7 @@
                 </a:solidFill>
                 <a:latin typeface="Klavika Regular"/>
               </a:rPr>
-              <a:t>Password: RadeonUnslothTuning</a:t>
+              <a:t>Studio password: RadeonUnslothStudio</a:t>
             </a:r>
           </a:p>
         </p:txBody>
@@ -27582,7 +27582,7 @@
                 </a:solidFill>
                 <a:latin typeface="Klavika Bold"/>
               </a:rPr>
-              <a:t>Notebook access</a:t>
+              <a:t>Workshop access</a:t>
             </a:r>
           </a:p>
         </p:txBody>
@@ -27609,7 +27609,7 @@
                 </a:solidFill>
                 <a:latin typeface="Klavika Light"/>
               </a:rPr>
-              <a:t>notebooks.amd.com/</a:t>
+              <a:t>Studio: localhost:8890   Notebook: localhost:8888</a:t>
             </a:r>
             <a:r>
               <a:rPr sz="2000" b="0" dirty="0" err="1">
@@ -27618,7 +27618,7 @@
                 </a:solidFill>
                 <a:latin typeface="Klavika Light"/>
               </a:rPr>
-              <a:t>ind</a:t>
+              <a:t/>
             </a:r>
             <a:r>
               <a:rPr sz="2000" b="0" dirty="0">
@@ -27627,7 +27627,7 @@
                 </a:solidFill>
                 <a:latin typeface="Klavika Light"/>
               </a:rPr>
-              <a:t>-dev</a:t>
+              <a:t/>
             </a:r>
           </a:p>
           <a:p>
@@ -27638,7 +27638,7 @@
                 </a:solidFill>
                 <a:latin typeface="Klavika Bold"/>
               </a:rPr>
-              <a:t>Password:  </a:t>
+              <a:t>Studio password:  </a:t>
             </a:r>
             <a:r>
               <a:rPr sz="2400" b="1" dirty="0" err="1">
@@ -27647,7 +27647,7 @@
                 </a:solidFill>
                 <a:latin typeface="Klavika Bold"/>
               </a:rPr>
-              <a:t>RadeonUnslothTuning</a:t>
+              <a:t>RadeonUnslothStudio</a:t>
             </a:r>
             <a:endParaRPr sz="2400" b="1" dirty="0">
               <a:solidFill>
@@ -28584,7 +28584,7 @@
                 </a:solidFill>
                 <a:latin typeface="Klavika Regular"/>
               </a:rPr>
-              <a:t>Our supervised task</a:t>
+              <a:t>The task we train for</a:t>
             </a:r>
           </a:p>
         </p:txBody>
@@ -28801,7 +28801,7 @@
                 </a:solidFill>
                 <a:latin typeface="Klavika Regular"/>
               </a:rPr>
-              <a:t>rocm-smi and rocminfo</a:t>
+              <a:t>hipInfo and Task Manager</a:t>
             </a:r>
           </a:p>
         </p:txBody>
@@ -29018,7 +29018,7 @@
                 </a:solidFill>
                 <a:latin typeface="Klavika Regular"/>
               </a:rPr>
-              <a:t>Train, compare, score, export</a:t>
+              <a:t>Train, test and export a model</a:t>
             </a:r>
           </a:p>
         </p:txBody>

</xml_diff>

<commit_message>
Deck: how SFT learns, reading a training run, stretch challenges
- New slide 9: one SFT training step (tokenize with the chat template,
  predict, cross-entropy loss, update only the LoRA adapter), with the
  batch/step arithmetic of this run.
- New slide 10: reading a training run, with the settings Studio used
  (lr 2e-4 with 5 warmup steps, batch 8 = 2 x 4, LoRA rank 16) and what
  the loss curve does and doesn't tell you.
- Slide 7: ~1% of weights trained (23M), the real figure for this run.
- Slide 8: SFT example in the chat format attendees upload, not Alpaca.
- New slides 20-21: stretch challenges (add a field, teach it your own
  task, export to GGUF) and own-task ideas with a write-5-generate-50
  workflow using the bigger model in Lemonade.
</commit_message>
<xml_diff>
--- a/docs/AMD-Unsloth-Studio-Fine-tuning.pptx
+++ b/docs/AMD-Unsloth-Studio-Fine-tuning.pptx
@@ -19,6 +19,8 @@
     <p:sldId id="260" r:id="rId68"/>
     <p:sldId id="261" r:id="rId69"/>
     <p:sldId id="262" r:id="rId70"/>
+    <p:sldId id="275" r:id="rId89"/>
+    <p:sldId id="276" r:id="rId90"/>
     <p:sldId id="263" r:id="rId71"/>
     <p:sldId id="264" r:id="rId72"/>
     <p:sldId id="265" r:id="rId73"/>
@@ -28,6 +30,8 @@
     <p:sldId id="269" r:id="rId77"/>
     <p:sldId id="270" r:id="rId78"/>
     <p:sldId id="271" r:id="rId79"/>
+    <p:sldId id="277" r:id="rId91"/>
+    <p:sldId id="278" r:id="rId92"/>
     <p:sldId id="272" r:id="rId80"/>
     <p:sldId id="273" r:id="rId81"/>
   </p:sldIdLst>
@@ -27666,6 +27670,4352 @@
 </p:sld>
 </file>
 
+<file path=ppt/slides/slide20.xml><?xml version="1.0" encoding="utf-8"?>
+<p:sld xmlns:a="http://schemas.openxmlformats.org/drawingml/2006/main" xmlns:p="http://schemas.openxmlformats.org/presentationml/2006/main" xmlns:r="http://schemas.openxmlformats.org/officeDocument/2006/relationships">
+  <p:cSld>
+    <p:bg>
+      <p:bgPr>
+        <a:blipFill rotWithShape="1">
+          <a:blip r:embed="rId2"/>
+          <a:stretch>
+            <a:fillRect/>
+          </a:stretch>
+        </a:blipFill>
+        <a:effectLst/>
+      </p:bgPr>
+    </p:bg>
+    <p:spTree>
+      <p:nvGrpSpPr>
+        <p:cNvPr id="1" name=""/>
+        <p:cNvGrpSpPr/>
+        <p:nvPr/>
+      </p:nvGrpSpPr>
+      <p:grpSpPr>
+        <a:xfrm>
+          <a:off x="0" y="0"/>
+          <a:ext cx="0" cy="0"/>
+          <a:chOff x="0" y="0"/>
+          <a:chExt cx="0" cy="0"/>
+        </a:xfrm>
+      </p:grpSpPr>
+      <p:sp>
+        <p:nvSpPr>
+          <p:cNvPr id="2" name="Title 1"/>
+          <p:cNvSpPr>
+            <a:spLocks noGrp="1"/>
+          </p:cNvSpPr>
+          <p:nvPr>
+            <p:ph type="title"/>
+          </p:nvPr>
+        </p:nvSpPr>
+        <p:spPr/>
+        <p:txBody>
+          <a:bodyPr/>
+          <a:lstStyle/>
+          <a:p>
+            <a:r>
+              <a:rPr sz="3200" b="0">
+                <a:solidFill>
+                  <a:srgbClr val="FFFFFF"/>
+                </a:solidFill>
+                <a:latin typeface="Klavika Bold"/>
+              </a:rPr>
+              <a:t>How SFT learns: one training step</a:t>
+            </a:r>
+          </a:p>
+        </p:txBody>
+      </p:sp>
+      <p:sp>
+        <p:nvSpPr>
+          <p:cNvPr id="3" name="TextBox 2"/>
+          <p:cNvSpPr txBox="1"/>
+          <p:nvPr/>
+        </p:nvSpPr>
+        <p:spPr>
+          <a:xfrm>
+            <a:off x="585216" y="1280160"/>
+            <a:ext cx="11018520" cy="640080"/>
+          </a:xfrm>
+          <a:prstGeom prst="rect">
+            <a:avLst/>
+          </a:prstGeom>
+          <a:noFill/>
+        </p:spPr>
+        <p:txBody>
+          <a:bodyPr wrap="square" lIns="0" tIns="0" rIns="0" bIns="0">
+            <a:spAutoFit/>
+          </a:bodyPr>
+          <a:lstStyle/>
+          <a:p>
+            <a:pPr algn="l">
+              <a:lnSpc>
+                <a:spcPct val="120000"/>
+              </a:lnSpc>
+              <a:spcBef>
+                <a:spcPts val="0"/>
+              </a:spcBef>
+              <a:spcAft>
+                <a:spcPts val="600"/>
+              </a:spcAft>
+            </a:pPr>
+            <a:r>
+              <a:rPr sz="1700" b="0">
+                <a:solidFill>
+                  <a:srgbClr val="D8DADE"/>
+                </a:solidFill>
+                <a:latin typeface="Klavika Regular"/>
+              </a:rPr>
+              <a:t>Each step shows the model a few examples and nudges it toward </a:t>
+            </a:r>
+            <a:r>
+              <a:rPr sz="1700" b="1">
+                <a:solidFill>
+                  <a:srgbClr val="F26522"/>
+                </a:solidFill>
+                <a:latin typeface="Klavika Bold"/>
+              </a:rPr>
+              <a:t>your</a:t>
+            </a:r>
+            <a:r>
+              <a:rPr sz="1700" b="0">
+                <a:solidFill>
+                  <a:srgbClr val="D8DADE"/>
+                </a:solidFill>
+                <a:latin typeface="Klavika Regular"/>
+              </a:rPr>
+              <a:t> answers, </a:t>
+            </a:r>
+            <a:r>
+              <a:rPr sz="1700" b="1">
+                <a:solidFill>
+                  <a:srgbClr val="F26522"/>
+                </a:solidFill>
+                <a:latin typeface="Klavika Bold"/>
+              </a:rPr>
+              <a:t>token by token</a:t>
+            </a:r>
+            <a:r>
+              <a:rPr sz="1700" b="0">
+                <a:solidFill>
+                  <a:srgbClr val="D8DADE"/>
+                </a:solidFill>
+                <a:latin typeface="Klavika Regular"/>
+              </a:rPr>
+              <a:t>.</a:t>
+            </a:r>
+          </a:p>
+        </p:txBody>
+      </p:sp>
+      <p:sp>
+        <p:nvSpPr>
+          <p:cNvPr id="4" name="Rectangle 3"/>
+          <p:cNvSpPr/>
+          <p:nvPr/>
+        </p:nvSpPr>
+        <p:spPr>
+          <a:xfrm>
+            <a:off x="585216" y="2148840"/>
+            <a:ext cx="2548890" cy="1847088"/>
+          </a:xfrm>
+          <a:prstGeom prst="rect">
+            <a:avLst/>
+          </a:prstGeom>
+          <a:solidFill>
+            <a:srgbClr val="1C1C1C"/>
+          </a:solidFill>
+          <a:ln w="9525">
+            <a:solidFill>
+              <a:srgbClr val="333333"/>
+            </a:solidFill>
+          </a:ln>
+          <a:effectLst/>
+        </p:spPr>
+        <p:style>
+          <a:lnRef idx="1">
+            <a:schemeClr val="accent1"/>
+          </a:lnRef>
+          <a:fillRef idx="3">
+            <a:schemeClr val="accent1"/>
+          </a:fillRef>
+          <a:effectRef idx="2">
+            <a:schemeClr val="accent1"/>
+          </a:effectRef>
+          <a:fontRef idx="minor">
+            <a:schemeClr val="lt1"/>
+          </a:fontRef>
+        </p:style>
+        <p:txBody>
+          <a:bodyPr rtlCol="0" anchor="ctr"/>
+          <a:lstStyle/>
+          <a:p>
+            <a:endParaRPr/>
+          </a:p>
+        </p:txBody>
+      </p:sp>
+      <p:sp>
+        <p:nvSpPr>
+          <p:cNvPr id="5" name="Rectangle 4"/>
+          <p:cNvSpPr/>
+          <p:nvPr/>
+        </p:nvSpPr>
+        <p:spPr>
+          <a:xfrm>
+            <a:off x="585216" y="2148840"/>
+            <a:ext cx="2548890" cy="64008"/>
+          </a:xfrm>
+          <a:prstGeom prst="rect">
+            <a:avLst/>
+          </a:prstGeom>
+          <a:solidFill>
+            <a:srgbClr val="F26522"/>
+          </a:solidFill>
+          <a:ln>
+            <a:noFill/>
+          </a:ln>
+          <a:effectLst/>
+        </p:spPr>
+        <p:style>
+          <a:lnRef idx="1">
+            <a:schemeClr val="accent1"/>
+          </a:lnRef>
+          <a:fillRef idx="3">
+            <a:schemeClr val="accent1"/>
+          </a:fillRef>
+          <a:effectRef idx="2">
+            <a:schemeClr val="accent1"/>
+          </a:effectRef>
+          <a:fontRef idx="minor">
+            <a:schemeClr val="lt1"/>
+          </a:fontRef>
+        </p:style>
+        <p:txBody>
+          <a:bodyPr rtlCol="0" anchor="ctr"/>
+          <a:lstStyle/>
+          <a:p>
+            <a:pPr algn="ctr"/>
+            <a:endParaRPr/>
+          </a:p>
+        </p:txBody>
+      </p:sp>
+      <p:sp>
+        <p:nvSpPr>
+          <p:cNvPr id="6" name="Oval 5"/>
+          <p:cNvSpPr/>
+          <p:nvPr/>
+        </p:nvSpPr>
+        <p:spPr>
+          <a:xfrm>
+            <a:off x="822960" y="2441448"/>
+            <a:ext cx="384048" cy="384048"/>
+          </a:xfrm>
+          <a:prstGeom prst="ellipse">
+            <a:avLst/>
+          </a:prstGeom>
+          <a:solidFill>
+            <a:srgbClr val="F26522"/>
+          </a:solidFill>
+          <a:ln>
+            <a:noFill/>
+          </a:ln>
+          <a:effectLst/>
+        </p:spPr>
+        <p:style>
+          <a:lnRef idx="1">
+            <a:schemeClr val="accent1"/>
+          </a:lnRef>
+          <a:fillRef idx="3">
+            <a:schemeClr val="accent1"/>
+          </a:fillRef>
+          <a:effectRef idx="2">
+            <a:schemeClr val="accent1"/>
+          </a:effectRef>
+          <a:fontRef idx="minor">
+            <a:schemeClr val="lt1"/>
+          </a:fontRef>
+        </p:style>
+        <p:txBody>
+          <a:bodyPr lIns="0" tIns="0" rIns="0" bIns="0" rtlCol="0" anchor="ctr"/>
+          <a:lstStyle/>
+          <a:p>
+            <a:pPr algn="ctr"/>
+            <a:r>
+              <a:rPr sz="1300">
+                <a:solidFill>
+                  <a:srgbClr val="FFFFFF"/>
+                </a:solidFill>
+                <a:latin typeface="Klavika Bold"/>
+              </a:rPr>
+              <a:t>1</a:t>
+            </a:r>
+          </a:p>
+        </p:txBody>
+      </p:sp>
+      <p:sp>
+        <p:nvSpPr>
+          <p:cNvPr id="7" name="TextBox 6"/>
+          <p:cNvSpPr txBox="1"/>
+          <p:nvPr/>
+        </p:nvSpPr>
+        <p:spPr>
+          <a:xfrm>
+            <a:off x="822960" y="2971800"/>
+            <a:ext cx="2073402" cy="274320"/>
+          </a:xfrm>
+          <a:prstGeom prst="rect">
+            <a:avLst/>
+          </a:prstGeom>
+          <a:noFill/>
+        </p:spPr>
+        <p:txBody>
+          <a:bodyPr wrap="square" lIns="0" tIns="0" rIns="0" bIns="0">
+            <a:spAutoFit/>
+          </a:bodyPr>
+          <a:lstStyle/>
+          <a:p>
+            <a:pPr algn="l">
+              <a:spcBef>
+                <a:spcPts val="0"/>
+              </a:spcBef>
+              <a:spcAft>
+                <a:spcPts val="600"/>
+              </a:spcAft>
+            </a:pPr>
+            <a:r>
+              <a:rPr sz="1600" b="0">
+                <a:solidFill>
+                  <a:srgbClr val="FFFFFF"/>
+                </a:solidFill>
+                <a:latin typeface="Klavika Bold"/>
+              </a:rPr>
+              <a:t>Tokenize</a:t>
+            </a:r>
+          </a:p>
+        </p:txBody>
+      </p:sp>
+      <p:sp>
+        <p:nvSpPr>
+          <p:cNvPr id="8" name="TextBox 7"/>
+          <p:cNvSpPr txBox="1"/>
+          <p:nvPr/>
+        </p:nvSpPr>
+        <p:spPr>
+          <a:xfrm>
+            <a:off x="822960" y="3282696"/>
+            <a:ext cx="2073402" cy="548640"/>
+          </a:xfrm>
+          <a:prstGeom prst="rect">
+            <a:avLst/>
+          </a:prstGeom>
+          <a:noFill/>
+        </p:spPr>
+        <p:txBody>
+          <a:bodyPr wrap="square" lIns="0" tIns="0" rIns="0" bIns="0">
+            <a:spAutoFit/>
+          </a:bodyPr>
+          <a:lstStyle/>
+          <a:p>
+            <a:pPr algn="l">
+              <a:lnSpc>
+                <a:spcPct val="115000"/>
+              </a:lnSpc>
+              <a:spcBef>
+                <a:spcPts val="0"/>
+              </a:spcBef>
+              <a:spcAft>
+                <a:spcPts val="600"/>
+              </a:spcAft>
+            </a:pPr>
+            <a:r>
+              <a:rPr sz="1250" b="0" dirty="0">
+                <a:solidFill>
+                  <a:srgbClr val="D8DADE"/>
+                </a:solidFill>
+                <a:latin typeface="Klavika Regular"/>
+              </a:rPr>
+              <a:t>The chat template turns the message and its ticket into one sequence of tokens.</a:t>
+            </a:r>
+          </a:p>
+        </p:txBody>
+      </p:sp>
+      <p:sp>
+        <p:nvSpPr>
+          <p:cNvPr id="9" name="Rectangle 8"/>
+          <p:cNvSpPr/>
+          <p:nvPr/>
+        </p:nvSpPr>
+        <p:spPr>
+          <a:xfrm>
+            <a:off x="3408426" y="2148840"/>
+            <a:ext cx="2548890" cy="1847088"/>
+          </a:xfrm>
+          <a:prstGeom prst="rect">
+            <a:avLst/>
+          </a:prstGeom>
+          <a:solidFill>
+            <a:srgbClr val="1C1C1C"/>
+          </a:solidFill>
+          <a:ln w="9525">
+            <a:solidFill>
+              <a:srgbClr val="333333"/>
+            </a:solidFill>
+          </a:ln>
+          <a:effectLst/>
+        </p:spPr>
+        <p:style>
+          <a:lnRef idx="1">
+            <a:schemeClr val="accent1"/>
+          </a:lnRef>
+          <a:fillRef idx="3">
+            <a:schemeClr val="accent1"/>
+          </a:fillRef>
+          <a:effectRef idx="2">
+            <a:schemeClr val="accent1"/>
+          </a:effectRef>
+          <a:fontRef idx="minor">
+            <a:schemeClr val="lt1"/>
+          </a:fontRef>
+        </p:style>
+        <p:txBody>
+          <a:bodyPr rtlCol="0" anchor="ctr"/>
+          <a:lstStyle/>
+          <a:p>
+            <a:endParaRPr/>
+          </a:p>
+        </p:txBody>
+      </p:sp>
+      <p:sp>
+        <p:nvSpPr>
+          <p:cNvPr id="10" name="Rectangle 9"/>
+          <p:cNvSpPr/>
+          <p:nvPr/>
+        </p:nvSpPr>
+        <p:spPr>
+          <a:xfrm>
+            <a:off x="3408426" y="2148840"/>
+            <a:ext cx="2548890" cy="64008"/>
+          </a:xfrm>
+          <a:prstGeom prst="rect">
+            <a:avLst/>
+          </a:prstGeom>
+          <a:solidFill>
+            <a:srgbClr val="007C97"/>
+          </a:solidFill>
+          <a:ln>
+            <a:noFill/>
+          </a:ln>
+          <a:effectLst/>
+        </p:spPr>
+        <p:style>
+          <a:lnRef idx="1">
+            <a:schemeClr val="accent1"/>
+          </a:lnRef>
+          <a:fillRef idx="3">
+            <a:schemeClr val="accent1"/>
+          </a:fillRef>
+          <a:effectRef idx="2">
+            <a:schemeClr val="accent1"/>
+          </a:effectRef>
+          <a:fontRef idx="minor">
+            <a:schemeClr val="lt1"/>
+          </a:fontRef>
+        </p:style>
+        <p:txBody>
+          <a:bodyPr rtlCol="0" anchor="ctr"/>
+          <a:lstStyle/>
+          <a:p>
+            <a:pPr algn="ctr"/>
+            <a:endParaRPr/>
+          </a:p>
+        </p:txBody>
+      </p:sp>
+      <p:sp>
+        <p:nvSpPr>
+          <p:cNvPr id="11" name="Oval 10"/>
+          <p:cNvSpPr/>
+          <p:nvPr/>
+        </p:nvSpPr>
+        <p:spPr>
+          <a:xfrm>
+            <a:off x="3646170" y="2441448"/>
+            <a:ext cx="384048" cy="384048"/>
+          </a:xfrm>
+          <a:prstGeom prst="ellipse">
+            <a:avLst/>
+          </a:prstGeom>
+          <a:solidFill>
+            <a:srgbClr val="007C97"/>
+          </a:solidFill>
+          <a:ln>
+            <a:noFill/>
+          </a:ln>
+          <a:effectLst/>
+        </p:spPr>
+        <p:style>
+          <a:lnRef idx="1">
+            <a:schemeClr val="accent1"/>
+          </a:lnRef>
+          <a:fillRef idx="3">
+            <a:schemeClr val="accent1"/>
+          </a:fillRef>
+          <a:effectRef idx="2">
+            <a:schemeClr val="accent1"/>
+          </a:effectRef>
+          <a:fontRef idx="minor">
+            <a:schemeClr val="lt1"/>
+          </a:fontRef>
+        </p:style>
+        <p:txBody>
+          <a:bodyPr lIns="0" tIns="0" rIns="0" bIns="0" rtlCol="0" anchor="ctr"/>
+          <a:lstStyle/>
+          <a:p>
+            <a:pPr algn="ctr"/>
+            <a:r>
+              <a:rPr sz="1300">
+                <a:solidFill>
+                  <a:srgbClr val="FFFFFF"/>
+                </a:solidFill>
+                <a:latin typeface="Klavika Bold"/>
+              </a:rPr>
+              <a:t>2</a:t>
+            </a:r>
+          </a:p>
+        </p:txBody>
+      </p:sp>
+      <p:sp>
+        <p:nvSpPr>
+          <p:cNvPr id="12" name="TextBox 11"/>
+          <p:cNvSpPr txBox="1"/>
+          <p:nvPr/>
+        </p:nvSpPr>
+        <p:spPr>
+          <a:xfrm>
+            <a:off x="3646170" y="2971800"/>
+            <a:ext cx="2073402" cy="274320"/>
+          </a:xfrm>
+          <a:prstGeom prst="rect">
+            <a:avLst/>
+          </a:prstGeom>
+          <a:noFill/>
+        </p:spPr>
+        <p:txBody>
+          <a:bodyPr wrap="square" lIns="0" tIns="0" rIns="0" bIns="0">
+            <a:spAutoFit/>
+          </a:bodyPr>
+          <a:lstStyle/>
+          <a:p>
+            <a:pPr algn="l">
+              <a:spcBef>
+                <a:spcPts val="0"/>
+              </a:spcBef>
+              <a:spcAft>
+                <a:spcPts val="600"/>
+              </a:spcAft>
+            </a:pPr>
+            <a:r>
+              <a:rPr sz="1600" b="0">
+                <a:solidFill>
+                  <a:srgbClr val="FFFFFF"/>
+                </a:solidFill>
+                <a:latin typeface="Klavika Bold"/>
+              </a:rPr>
+              <a:t>Predict</a:t>
+            </a:r>
+          </a:p>
+        </p:txBody>
+      </p:sp>
+      <p:sp>
+        <p:nvSpPr>
+          <p:cNvPr id="13" name="TextBox 12"/>
+          <p:cNvSpPr txBox="1"/>
+          <p:nvPr/>
+        </p:nvSpPr>
+        <p:spPr>
+          <a:xfrm>
+            <a:off x="3646170" y="3282696"/>
+            <a:ext cx="2073402" cy="548640"/>
+          </a:xfrm>
+          <a:prstGeom prst="rect">
+            <a:avLst/>
+          </a:prstGeom>
+          <a:noFill/>
+        </p:spPr>
+        <p:txBody>
+          <a:bodyPr wrap="square" lIns="0" tIns="0" rIns="0" bIns="0">
+            <a:spAutoFit/>
+          </a:bodyPr>
+          <a:lstStyle/>
+          <a:p>
+            <a:pPr algn="l">
+              <a:lnSpc>
+                <a:spcPct val="115000"/>
+              </a:lnSpc>
+              <a:spcBef>
+                <a:spcPts val="0"/>
+              </a:spcBef>
+              <a:spcAft>
+                <a:spcPts val="600"/>
+              </a:spcAft>
+            </a:pPr>
+            <a:r>
+              <a:rPr sz="1250" b="0" dirty="0">
+                <a:solidFill>
+                  <a:srgbClr val="D8DADE"/>
+                </a:solidFill>
+                <a:latin typeface="Klavika Regular"/>
+              </a:rPr>
+              <a:t>At every position the model guesses the next token, just as when it chats.</a:t>
+            </a:r>
+          </a:p>
+        </p:txBody>
+      </p:sp>
+      <p:sp>
+        <p:nvSpPr>
+          <p:cNvPr id="14" name="Rectangle 13"/>
+          <p:cNvSpPr/>
+          <p:nvPr/>
+        </p:nvSpPr>
+        <p:spPr>
+          <a:xfrm>
+            <a:off x="6231636" y="2148840"/>
+            <a:ext cx="2548890" cy="1847088"/>
+          </a:xfrm>
+          <a:prstGeom prst="rect">
+            <a:avLst/>
+          </a:prstGeom>
+          <a:solidFill>
+            <a:srgbClr val="1C1C1C"/>
+          </a:solidFill>
+          <a:ln w="9525">
+            <a:solidFill>
+              <a:srgbClr val="333333"/>
+            </a:solidFill>
+          </a:ln>
+          <a:effectLst/>
+        </p:spPr>
+        <p:style>
+          <a:lnRef idx="1">
+            <a:schemeClr val="accent1"/>
+          </a:lnRef>
+          <a:fillRef idx="3">
+            <a:schemeClr val="accent1"/>
+          </a:fillRef>
+          <a:effectRef idx="2">
+            <a:schemeClr val="accent1"/>
+          </a:effectRef>
+          <a:fontRef idx="minor">
+            <a:schemeClr val="lt1"/>
+          </a:fontRef>
+        </p:style>
+        <p:txBody>
+          <a:bodyPr rtlCol="0" anchor="ctr"/>
+          <a:lstStyle/>
+          <a:p>
+            <a:endParaRPr/>
+          </a:p>
+        </p:txBody>
+      </p:sp>
+      <p:sp>
+        <p:nvSpPr>
+          <p:cNvPr id="15" name="Rectangle 14"/>
+          <p:cNvSpPr/>
+          <p:nvPr/>
+        </p:nvSpPr>
+        <p:spPr>
+          <a:xfrm>
+            <a:off x="6231636" y="2148840"/>
+            <a:ext cx="2548890" cy="64008"/>
+          </a:xfrm>
+          <a:prstGeom prst="rect">
+            <a:avLst/>
+          </a:prstGeom>
+          <a:solidFill>
+            <a:srgbClr val="ED1C24"/>
+          </a:solidFill>
+          <a:ln>
+            <a:noFill/>
+          </a:ln>
+          <a:effectLst/>
+        </p:spPr>
+        <p:style>
+          <a:lnRef idx="1">
+            <a:schemeClr val="accent1"/>
+          </a:lnRef>
+          <a:fillRef idx="3">
+            <a:schemeClr val="accent1"/>
+          </a:fillRef>
+          <a:effectRef idx="2">
+            <a:schemeClr val="accent1"/>
+          </a:effectRef>
+          <a:fontRef idx="minor">
+            <a:schemeClr val="lt1"/>
+          </a:fontRef>
+        </p:style>
+        <p:txBody>
+          <a:bodyPr rtlCol="0" anchor="ctr"/>
+          <a:lstStyle/>
+          <a:p>
+            <a:pPr algn="ctr"/>
+            <a:endParaRPr/>
+          </a:p>
+        </p:txBody>
+      </p:sp>
+      <p:sp>
+        <p:nvSpPr>
+          <p:cNvPr id="16" name="Oval 15"/>
+          <p:cNvSpPr/>
+          <p:nvPr/>
+        </p:nvSpPr>
+        <p:spPr>
+          <a:xfrm>
+            <a:off x="6469379" y="2441448"/>
+            <a:ext cx="384048" cy="384048"/>
+          </a:xfrm>
+          <a:prstGeom prst="ellipse">
+            <a:avLst/>
+          </a:prstGeom>
+          <a:solidFill>
+            <a:srgbClr val="ED1C24"/>
+          </a:solidFill>
+          <a:ln>
+            <a:noFill/>
+          </a:ln>
+          <a:effectLst/>
+        </p:spPr>
+        <p:style>
+          <a:lnRef idx="1">
+            <a:schemeClr val="accent1"/>
+          </a:lnRef>
+          <a:fillRef idx="3">
+            <a:schemeClr val="accent1"/>
+          </a:fillRef>
+          <a:effectRef idx="2">
+            <a:schemeClr val="accent1"/>
+          </a:effectRef>
+          <a:fontRef idx="minor">
+            <a:schemeClr val="lt1"/>
+          </a:fontRef>
+        </p:style>
+        <p:txBody>
+          <a:bodyPr lIns="0" tIns="0" rIns="0" bIns="0" rtlCol="0" anchor="ctr"/>
+          <a:lstStyle/>
+          <a:p>
+            <a:pPr algn="ctr"/>
+            <a:r>
+              <a:rPr sz="1300">
+                <a:solidFill>
+                  <a:srgbClr val="FFFFFF"/>
+                </a:solidFill>
+                <a:latin typeface="Klavika Bold"/>
+              </a:rPr>
+              <a:t>3</a:t>
+            </a:r>
+          </a:p>
+        </p:txBody>
+      </p:sp>
+      <p:sp>
+        <p:nvSpPr>
+          <p:cNvPr id="17" name="TextBox 16"/>
+          <p:cNvSpPr txBox="1"/>
+          <p:nvPr/>
+        </p:nvSpPr>
+        <p:spPr>
+          <a:xfrm>
+            <a:off x="6469379" y="2971800"/>
+            <a:ext cx="2073402" cy="274320"/>
+          </a:xfrm>
+          <a:prstGeom prst="rect">
+            <a:avLst/>
+          </a:prstGeom>
+          <a:noFill/>
+        </p:spPr>
+        <p:txBody>
+          <a:bodyPr wrap="square" lIns="0" tIns="0" rIns="0" bIns="0">
+            <a:spAutoFit/>
+          </a:bodyPr>
+          <a:lstStyle/>
+          <a:p>
+            <a:pPr algn="l">
+              <a:spcBef>
+                <a:spcPts val="0"/>
+              </a:spcBef>
+              <a:spcAft>
+                <a:spcPts val="600"/>
+              </a:spcAft>
+            </a:pPr>
+            <a:r>
+              <a:rPr sz="1600" b="0">
+                <a:solidFill>
+                  <a:srgbClr val="FFFFFF"/>
+                </a:solidFill>
+                <a:latin typeface="Klavika Bold"/>
+              </a:rPr>
+              <a:t>Measure</a:t>
+            </a:r>
+          </a:p>
+        </p:txBody>
+      </p:sp>
+      <p:sp>
+        <p:nvSpPr>
+          <p:cNvPr id="18" name="TextBox 17"/>
+          <p:cNvSpPr txBox="1"/>
+          <p:nvPr/>
+        </p:nvSpPr>
+        <p:spPr>
+          <a:xfrm>
+            <a:off x="6469379" y="3282696"/>
+            <a:ext cx="2073402" cy="435247"/>
+          </a:xfrm>
+          <a:prstGeom prst="rect">
+            <a:avLst/>
+          </a:prstGeom>
+          <a:noFill/>
+        </p:spPr>
+        <p:txBody>
+          <a:bodyPr wrap="square" lIns="0" tIns="0" rIns="0" bIns="0">
+            <a:spAutoFit/>
+          </a:bodyPr>
+          <a:lstStyle/>
+          <a:p>
+            <a:pPr algn="l">
+              <a:lnSpc>
+                <a:spcPct val="115000"/>
+              </a:lnSpc>
+              <a:spcBef>
+                <a:spcPts val="0"/>
+              </a:spcBef>
+              <a:spcAft>
+                <a:spcPts val="600"/>
+              </a:spcAft>
+            </a:pPr>
+            <a:r>
+              <a:rPr sz="1250" b="0" dirty="0">
+                <a:solidFill>
+                  <a:srgbClr val="D8DADE"/>
+                </a:solidFill>
+                <a:latin typeface="Klavika Regular"/>
+              </a:rPr>
+              <a:t>Cross-entropy loss: how unlikely it found the real next token. Lower is better.</a:t>
+            </a:r>
+            <a:r>
+              <a:rPr lang="en-US" sz="1250" b="0" dirty="0">
+                <a:solidFill>
+                  <a:srgbClr val="D8DADE"/>
+                </a:solidFill>
+                <a:latin typeface="Klavika Regular"/>
+              </a:rPr>
+              <a:t/>
+            </a:r>
+            <a:endParaRPr sz="1250" b="0" dirty="0">
+              <a:solidFill>
+                <a:srgbClr val="D8DADE"/>
+              </a:solidFill>
+              <a:latin typeface="Klavika Regular"/>
+            </a:endParaRPr>
+          </a:p>
+        </p:txBody>
+      </p:sp>
+      <p:sp>
+        <p:nvSpPr>
+          <p:cNvPr id="19" name="Rectangle 18"/>
+          <p:cNvSpPr/>
+          <p:nvPr/>
+        </p:nvSpPr>
+        <p:spPr>
+          <a:xfrm>
+            <a:off x="9054846" y="2148840"/>
+            <a:ext cx="2548890" cy="1847088"/>
+          </a:xfrm>
+          <a:prstGeom prst="rect">
+            <a:avLst/>
+          </a:prstGeom>
+          <a:solidFill>
+            <a:srgbClr val="1C1C1C"/>
+          </a:solidFill>
+          <a:ln w="9525">
+            <a:solidFill>
+              <a:srgbClr val="333333"/>
+            </a:solidFill>
+          </a:ln>
+          <a:effectLst/>
+        </p:spPr>
+        <p:style>
+          <a:lnRef idx="1">
+            <a:schemeClr val="accent1"/>
+          </a:lnRef>
+          <a:fillRef idx="3">
+            <a:schemeClr val="accent1"/>
+          </a:fillRef>
+          <a:effectRef idx="2">
+            <a:schemeClr val="accent1"/>
+          </a:effectRef>
+          <a:fontRef idx="minor">
+            <a:schemeClr val="lt1"/>
+          </a:fontRef>
+        </p:style>
+        <p:txBody>
+          <a:bodyPr rtlCol="0" anchor="ctr"/>
+          <a:lstStyle/>
+          <a:p>
+            <a:endParaRPr/>
+          </a:p>
+        </p:txBody>
+      </p:sp>
+      <p:sp>
+        <p:nvSpPr>
+          <p:cNvPr id="20" name="Rectangle 19"/>
+          <p:cNvSpPr/>
+          <p:nvPr/>
+        </p:nvSpPr>
+        <p:spPr>
+          <a:xfrm>
+            <a:off x="9054846" y="2148840"/>
+            <a:ext cx="2548890" cy="64008"/>
+          </a:xfrm>
+          <a:prstGeom prst="rect">
+            <a:avLst/>
+          </a:prstGeom>
+          <a:solidFill>
+            <a:srgbClr val="F26522"/>
+          </a:solidFill>
+          <a:ln>
+            <a:noFill/>
+          </a:ln>
+          <a:effectLst/>
+        </p:spPr>
+        <p:style>
+          <a:lnRef idx="1">
+            <a:schemeClr val="accent1"/>
+          </a:lnRef>
+          <a:fillRef idx="3">
+            <a:schemeClr val="accent1"/>
+          </a:fillRef>
+          <a:effectRef idx="2">
+            <a:schemeClr val="accent1"/>
+          </a:effectRef>
+          <a:fontRef idx="minor">
+            <a:schemeClr val="lt1"/>
+          </a:fontRef>
+        </p:style>
+        <p:txBody>
+          <a:bodyPr rtlCol="0" anchor="ctr"/>
+          <a:lstStyle/>
+          <a:p>
+            <a:pPr algn="ctr"/>
+            <a:endParaRPr/>
+          </a:p>
+        </p:txBody>
+      </p:sp>
+      <p:sp>
+        <p:nvSpPr>
+          <p:cNvPr id="21" name="Oval 20"/>
+          <p:cNvSpPr/>
+          <p:nvPr/>
+        </p:nvSpPr>
+        <p:spPr>
+          <a:xfrm>
+            <a:off x="9292590" y="2441448"/>
+            <a:ext cx="384048" cy="384048"/>
+          </a:xfrm>
+          <a:prstGeom prst="ellipse">
+            <a:avLst/>
+          </a:prstGeom>
+          <a:solidFill>
+            <a:srgbClr val="F26522"/>
+          </a:solidFill>
+          <a:ln>
+            <a:noFill/>
+          </a:ln>
+          <a:effectLst/>
+        </p:spPr>
+        <p:style>
+          <a:lnRef idx="1">
+            <a:schemeClr val="accent1"/>
+          </a:lnRef>
+          <a:fillRef idx="3">
+            <a:schemeClr val="accent1"/>
+          </a:fillRef>
+          <a:effectRef idx="2">
+            <a:schemeClr val="accent1"/>
+          </a:effectRef>
+          <a:fontRef idx="minor">
+            <a:schemeClr val="lt1"/>
+          </a:fontRef>
+        </p:style>
+        <p:txBody>
+          <a:bodyPr lIns="0" tIns="0" rIns="0" bIns="0" rtlCol="0" anchor="ctr"/>
+          <a:lstStyle/>
+          <a:p>
+            <a:pPr algn="ctr"/>
+            <a:r>
+              <a:rPr sz="1300">
+                <a:solidFill>
+                  <a:srgbClr val="FFFFFF"/>
+                </a:solidFill>
+                <a:latin typeface="Klavika Bold"/>
+              </a:rPr>
+              <a:t>4</a:t>
+            </a:r>
+          </a:p>
+        </p:txBody>
+      </p:sp>
+      <p:sp>
+        <p:nvSpPr>
+          <p:cNvPr id="22" name="TextBox 21"/>
+          <p:cNvSpPr txBox="1"/>
+          <p:nvPr/>
+        </p:nvSpPr>
+        <p:spPr>
+          <a:xfrm>
+            <a:off x="9292590" y="2971800"/>
+            <a:ext cx="2073402" cy="274320"/>
+          </a:xfrm>
+          <a:prstGeom prst="rect">
+            <a:avLst/>
+          </a:prstGeom>
+          <a:noFill/>
+        </p:spPr>
+        <p:txBody>
+          <a:bodyPr wrap="square" lIns="0" tIns="0" rIns="0" bIns="0">
+            <a:spAutoFit/>
+          </a:bodyPr>
+          <a:lstStyle/>
+          <a:p>
+            <a:pPr algn="l">
+              <a:spcBef>
+                <a:spcPts val="0"/>
+              </a:spcBef>
+              <a:spcAft>
+                <a:spcPts val="600"/>
+              </a:spcAft>
+            </a:pPr>
+            <a:r>
+              <a:rPr sz="1600" b="0">
+                <a:solidFill>
+                  <a:srgbClr val="FFFFFF"/>
+                </a:solidFill>
+                <a:latin typeface="Klavika Bold"/>
+              </a:rPr>
+              <a:t>Update</a:t>
+            </a:r>
+          </a:p>
+        </p:txBody>
+      </p:sp>
+      <p:sp>
+        <p:nvSpPr>
+          <p:cNvPr id="23" name="TextBox 22"/>
+          <p:cNvSpPr txBox="1"/>
+          <p:nvPr/>
+        </p:nvSpPr>
+        <p:spPr>
+          <a:xfrm>
+            <a:off x="9292590" y="3282696"/>
+            <a:ext cx="2073402" cy="548640"/>
+          </a:xfrm>
+          <a:prstGeom prst="rect">
+            <a:avLst/>
+          </a:prstGeom>
+          <a:noFill/>
+        </p:spPr>
+        <p:txBody>
+          <a:bodyPr wrap="square" lIns="0" tIns="0" rIns="0" bIns="0">
+            <a:spAutoFit/>
+          </a:bodyPr>
+          <a:lstStyle/>
+          <a:p>
+            <a:pPr algn="l">
+              <a:lnSpc>
+                <a:spcPct val="115000"/>
+              </a:lnSpc>
+              <a:spcBef>
+                <a:spcPts val="0"/>
+              </a:spcBef>
+              <a:spcAft>
+                <a:spcPts val="600"/>
+              </a:spcAft>
+            </a:pPr>
+            <a:r>
+              <a:rPr sz="1250" b="0">
+                <a:solidFill>
+                  <a:srgbClr val="D8DADE"/>
+                </a:solidFill>
+                <a:latin typeface="Klavika Regular"/>
+              </a:rPr>
+              <a:t>Backpropagation adjusts only the LoRA adapter, making the right tokens likelier.</a:t>
+            </a:r>
+          </a:p>
+        </p:txBody>
+      </p:sp>
+      <p:sp>
+        <p:nvSpPr>
+          <p:cNvPr id="24" name="Rectangle 23"/>
+          <p:cNvSpPr/>
+          <p:nvPr/>
+        </p:nvSpPr>
+        <p:spPr>
+          <a:xfrm>
+            <a:off x="585216" y="4315968"/>
+            <a:ext cx="11018520" cy="841248"/>
+          </a:xfrm>
+          <a:prstGeom prst="rect">
+            <a:avLst/>
+          </a:prstGeom>
+          <a:solidFill>
+            <a:srgbClr val="151515"/>
+          </a:solidFill>
+          <a:ln w="9525">
+            <a:solidFill>
+              <a:srgbClr val="333333"/>
+            </a:solidFill>
+          </a:ln>
+          <a:effectLst/>
+        </p:spPr>
+        <p:style>
+          <a:lnRef idx="1">
+            <a:schemeClr val="accent1"/>
+          </a:lnRef>
+          <a:fillRef idx="3">
+            <a:schemeClr val="accent1"/>
+          </a:fillRef>
+          <a:effectRef idx="2">
+            <a:schemeClr val="accent1"/>
+          </a:effectRef>
+          <a:fontRef idx="minor">
+            <a:schemeClr val="lt1"/>
+          </a:fontRef>
+        </p:style>
+        <p:txBody>
+          <a:bodyPr rtlCol="0" anchor="ctr"/>
+          <a:lstStyle/>
+          <a:p>
+            <a:endParaRPr/>
+          </a:p>
+        </p:txBody>
+      </p:sp>
+      <p:sp>
+        <p:nvSpPr>
+          <p:cNvPr id="25" name="Rectangle 24"/>
+          <p:cNvSpPr/>
+          <p:nvPr/>
+        </p:nvSpPr>
+        <p:spPr>
+          <a:xfrm>
+            <a:off x="585216" y="4315968"/>
+            <a:ext cx="64008" cy="841248"/>
+          </a:xfrm>
+          <a:prstGeom prst="rect">
+            <a:avLst/>
+          </a:prstGeom>
+          <a:solidFill>
+            <a:srgbClr val="007C97"/>
+          </a:solidFill>
+          <a:ln>
+            <a:noFill/>
+          </a:ln>
+          <a:effectLst/>
+        </p:spPr>
+        <p:style>
+          <a:lnRef idx="1">
+            <a:schemeClr val="accent1"/>
+          </a:lnRef>
+          <a:fillRef idx="3">
+            <a:schemeClr val="accent1"/>
+          </a:fillRef>
+          <a:effectRef idx="2">
+            <a:schemeClr val="accent1"/>
+          </a:effectRef>
+          <a:fontRef idx="minor">
+            <a:schemeClr val="lt1"/>
+          </a:fontRef>
+        </p:style>
+        <p:txBody>
+          <a:bodyPr rtlCol="0" anchor="ctr"/>
+          <a:lstStyle/>
+          <a:p>
+            <a:pPr algn="ctr"/>
+            <a:endParaRPr/>
+          </a:p>
+        </p:txBody>
+      </p:sp>
+      <p:sp>
+        <p:nvSpPr>
+          <p:cNvPr id="26" name="TextBox 25"/>
+          <p:cNvSpPr txBox="1"/>
+          <p:nvPr/>
+        </p:nvSpPr>
+        <p:spPr>
+          <a:xfrm>
+            <a:off x="877824" y="4462272"/>
+            <a:ext cx="10378440" cy="543931"/>
+          </a:xfrm>
+          <a:prstGeom prst="rect">
+            <a:avLst/>
+          </a:prstGeom>
+          <a:noFill/>
+        </p:spPr>
+        <p:txBody>
+          <a:bodyPr wrap="square" lIns="0" tIns="0" rIns="0" bIns="0">
+            <a:spAutoFit/>
+          </a:bodyPr>
+          <a:lstStyle/>
+          <a:p>
+            <a:pPr algn="l">
+              <a:lnSpc>
+                <a:spcPct val="125000"/>
+              </a:lnSpc>
+              <a:spcBef>
+                <a:spcPts val="0"/>
+              </a:spcBef>
+              <a:spcAft>
+                <a:spcPts val="600"/>
+              </a:spcAft>
+            </a:pPr>
+            <a:r>
+              <a:rPr sz="1450" b="1" dirty="0">
+                <a:solidFill>
+                  <a:srgbClr val="FFFFFF"/>
+                </a:solidFill>
+                <a:latin typeface="Klavika Bold"/>
+              </a:rPr>
+              <a:t>One step is 8 examples. </a:t>
+            </a:r>
+            <a:r>
+              <a:rPr sz="1450" b="0" dirty="0">
+                <a:solidFill>
+                  <a:srgbClr val="D8DADE"/>
+                </a:solidFill>
+                <a:latin typeface="Klavika Regular"/>
+              </a:rPr>
+              <a:t>30 steps show the model 240 tickets, about a quarter of the data. </a:t>
+            </a:r>
+            <a:r>
+              <a:rPr sz="1450" b="1" dirty="0">
+                <a:solidFill>
+                  <a:srgbClr val="00A8CC"/>
+                </a:solidFill>
+                <a:latin typeface="Klavika Bold"/>
+              </a:rPr>
+              <a:t>The test tickets are never trained on, which is why the notebook scores on them.</a:t>
+            </a:r>
+          </a:p>
+        </p:txBody>
+      </p:sp>
+    </p:spTree>
+  </p:cSld>
+  <p:clrMapOvr>
+    <a:masterClrMapping/>
+  </p:clrMapOvr>
+</p:sld>
+</file>
+
+<file path=ppt/slides/slide21.xml><?xml version="1.0" encoding="utf-8"?>
+<p:sld xmlns:a="http://schemas.openxmlformats.org/drawingml/2006/main" xmlns:p="http://schemas.openxmlformats.org/presentationml/2006/main" xmlns:r="http://schemas.openxmlformats.org/officeDocument/2006/relationships">
+  <p:cSld>
+    <p:bg>
+      <p:bgPr>
+        <a:blipFill rotWithShape="1">
+          <a:blip r:embed="rId2"/>
+          <a:stretch>
+            <a:fillRect/>
+          </a:stretch>
+        </a:blipFill>
+        <a:effectLst/>
+      </p:bgPr>
+    </p:bg>
+    <p:spTree>
+      <p:nvGrpSpPr>
+        <p:cNvPr id="1" name=""/>
+        <p:cNvGrpSpPr/>
+        <p:nvPr/>
+      </p:nvGrpSpPr>
+      <p:grpSpPr>
+        <a:xfrm>
+          <a:off x="0" y="0"/>
+          <a:ext cx="0" cy="0"/>
+          <a:chOff x="0" y="0"/>
+          <a:chExt cx="0" cy="0"/>
+        </a:xfrm>
+      </p:grpSpPr>
+      <p:sp>
+        <p:nvSpPr>
+          <p:cNvPr id="2" name="Title 1"/>
+          <p:cNvSpPr>
+            <a:spLocks noGrp="1"/>
+          </p:cNvSpPr>
+          <p:nvPr>
+            <p:ph type="title"/>
+          </p:nvPr>
+        </p:nvSpPr>
+        <p:spPr/>
+        <p:txBody>
+          <a:bodyPr/>
+          <a:lstStyle/>
+          <a:p>
+            <a:r>
+              <a:rPr sz="3200" b="0">
+                <a:solidFill>
+                  <a:srgbClr val="FFFFFF"/>
+                </a:solidFill>
+                <a:latin typeface="Klavika Bold"/>
+              </a:rPr>
+              <a:t>Reading a training run</a:t>
+            </a:r>
+          </a:p>
+        </p:txBody>
+      </p:sp>
+      <p:sp>
+        <p:nvSpPr>
+          <p:cNvPr id="3" name="TextBox 2"/>
+          <p:cNvSpPr txBox="1"/>
+          <p:nvPr/>
+        </p:nvSpPr>
+        <p:spPr>
+          <a:xfrm>
+            <a:off x="585216" y="1280160"/>
+            <a:ext cx="11018520" cy="365760"/>
+          </a:xfrm>
+          <a:prstGeom prst="rect">
+            <a:avLst/>
+          </a:prstGeom>
+          <a:noFill/>
+        </p:spPr>
+        <p:txBody>
+          <a:bodyPr wrap="square" lIns="0" tIns="0" rIns="0" bIns="0">
+            <a:spAutoFit/>
+          </a:bodyPr>
+          <a:lstStyle/>
+          <a:p>
+            <a:pPr algn="l">
+              <a:spcBef>
+                <a:spcPts val="0"/>
+              </a:spcBef>
+              <a:spcAft>
+                <a:spcPts val="600"/>
+              </a:spcAft>
+            </a:pPr>
+            <a:r>
+              <a:rPr sz="1600" b="0" dirty="0">
+                <a:solidFill>
+                  <a:srgbClr val="D8DADE"/>
+                </a:solidFill>
+                <a:latin typeface="Klavika Regular"/>
+              </a:rPr>
+              <a:t>The settings Studio used today, and what the loss chart tells you.</a:t>
+            </a:r>
+          </a:p>
+        </p:txBody>
+      </p:sp>
+      <p:sp>
+        <p:nvSpPr>
+          <p:cNvPr id="4" name="Rectangle 3"/>
+          <p:cNvSpPr/>
+          <p:nvPr/>
+        </p:nvSpPr>
+        <p:spPr>
+          <a:xfrm>
+            <a:off x="585216" y="1920240"/>
+            <a:ext cx="5349240" cy="2331720"/>
+          </a:xfrm>
+          <a:prstGeom prst="rect">
+            <a:avLst/>
+          </a:prstGeom>
+          <a:solidFill>
+            <a:srgbClr val="1C1C1C"/>
+          </a:solidFill>
+          <a:ln w="9525">
+            <a:solidFill>
+              <a:srgbClr val="333333"/>
+            </a:solidFill>
+          </a:ln>
+          <a:effectLst/>
+        </p:spPr>
+        <p:style>
+          <a:lnRef idx="1">
+            <a:schemeClr val="accent1"/>
+          </a:lnRef>
+          <a:fillRef idx="3">
+            <a:schemeClr val="accent1"/>
+          </a:fillRef>
+          <a:effectRef idx="2">
+            <a:schemeClr val="accent1"/>
+          </a:effectRef>
+          <a:fontRef idx="minor">
+            <a:schemeClr val="lt1"/>
+          </a:fontRef>
+        </p:style>
+        <p:txBody>
+          <a:bodyPr rtlCol="0" anchor="ctr"/>
+          <a:lstStyle/>
+          <a:p>
+            <a:endParaRPr/>
+          </a:p>
+        </p:txBody>
+      </p:sp>
+      <p:sp>
+        <p:nvSpPr>
+          <p:cNvPr id="5" name="Rectangle 4"/>
+          <p:cNvSpPr/>
+          <p:nvPr/>
+        </p:nvSpPr>
+        <p:spPr>
+          <a:xfrm>
+            <a:off x="585216" y="1920240"/>
+            <a:ext cx="5349240" cy="64008"/>
+          </a:xfrm>
+          <a:prstGeom prst="rect">
+            <a:avLst/>
+          </a:prstGeom>
+          <a:solidFill>
+            <a:srgbClr val="F26522"/>
+          </a:solidFill>
+          <a:ln>
+            <a:noFill/>
+          </a:ln>
+          <a:effectLst/>
+        </p:spPr>
+        <p:style>
+          <a:lnRef idx="1">
+            <a:schemeClr val="accent1"/>
+          </a:lnRef>
+          <a:fillRef idx="3">
+            <a:schemeClr val="accent1"/>
+          </a:fillRef>
+          <a:effectRef idx="2">
+            <a:schemeClr val="accent1"/>
+          </a:effectRef>
+          <a:fontRef idx="minor">
+            <a:schemeClr val="lt1"/>
+          </a:fontRef>
+        </p:style>
+        <p:txBody>
+          <a:bodyPr rtlCol="0" anchor="ctr"/>
+          <a:lstStyle/>
+          <a:p>
+            <a:pPr algn="ctr"/>
+            <a:endParaRPr/>
+          </a:p>
+        </p:txBody>
+      </p:sp>
+      <p:sp>
+        <p:nvSpPr>
+          <p:cNvPr id="6" name="Rounded Rectangle 5"/>
+          <p:cNvSpPr/>
+          <p:nvPr/>
+        </p:nvSpPr>
+        <p:spPr>
+          <a:xfrm>
+            <a:off x="841248" y="2212848"/>
+            <a:ext cx="1051560" cy="274320"/>
+          </a:xfrm>
+          <a:prstGeom prst="roundRect">
+            <a:avLst/>
+          </a:prstGeom>
+          <a:solidFill>
+            <a:srgbClr val="F26522"/>
+          </a:solidFill>
+          <a:ln>
+            <a:noFill/>
+          </a:ln>
+          <a:effectLst/>
+        </p:spPr>
+        <p:style>
+          <a:lnRef idx="1">
+            <a:schemeClr val="accent1"/>
+          </a:lnRef>
+          <a:fillRef idx="3">
+            <a:schemeClr val="accent1"/>
+          </a:fillRef>
+          <a:effectRef idx="2">
+            <a:schemeClr val="accent1"/>
+          </a:effectRef>
+          <a:fontRef idx="minor">
+            <a:schemeClr val="lt1"/>
+          </a:fontRef>
+        </p:style>
+        <p:txBody>
+          <a:bodyPr wrap="none" lIns="0" tIns="0" rIns="0" bIns="0" rtlCol="0" anchor="ctr"/>
+          <a:lstStyle/>
+          <a:p>
+            <a:pPr algn="ctr"/>
+            <a:r>
+              <a:rPr sz="1100">
+                <a:solidFill>
+                  <a:srgbClr val="FFFFFF"/>
+                </a:solidFill>
+                <a:latin typeface="Klavika Bold"/>
+              </a:rPr>
+              <a:t>Knobs</a:t>
+            </a:r>
+          </a:p>
+        </p:txBody>
+      </p:sp>
+      <p:sp>
+        <p:nvSpPr>
+          <p:cNvPr id="7" name="TextBox 6"/>
+          <p:cNvSpPr txBox="1"/>
+          <p:nvPr/>
+        </p:nvSpPr>
+        <p:spPr>
+          <a:xfrm>
+            <a:off x="2002536" y="2249424"/>
+            <a:ext cx="3611880" cy="256032"/>
+          </a:xfrm>
+          <a:prstGeom prst="rect">
+            <a:avLst/>
+          </a:prstGeom>
+          <a:noFill/>
+        </p:spPr>
+        <p:txBody>
+          <a:bodyPr wrap="square" lIns="0" tIns="0" rIns="0" bIns="0">
+            <a:spAutoFit/>
+          </a:bodyPr>
+          <a:lstStyle/>
+          <a:p>
+            <a:pPr algn="l">
+              <a:spcBef>
+                <a:spcPts val="0"/>
+              </a:spcBef>
+              <a:spcAft>
+                <a:spcPts val="600"/>
+              </a:spcAft>
+            </a:pPr>
+            <a:r>
+              <a:rPr sz="1400" b="0">
+                <a:solidFill>
+                  <a:srgbClr val="C6C8CC"/>
+                </a:solidFill>
+                <a:latin typeface="Klavika Medium"/>
+              </a:rPr>
+              <a:t>Studio's defaults for this run</a:t>
+            </a:r>
+          </a:p>
+        </p:txBody>
+      </p:sp>
+      <p:sp>
+        <p:nvSpPr>
+          <p:cNvPr id="8" name="TextBox 7"/>
+          <p:cNvSpPr txBox="1"/>
+          <p:nvPr/>
+        </p:nvSpPr>
+        <p:spPr>
+          <a:xfrm>
+            <a:off x="841248" y="2697480"/>
+            <a:ext cx="4837176" cy="828432"/>
+          </a:xfrm>
+          <a:prstGeom prst="rect">
+            <a:avLst/>
+          </a:prstGeom>
+          <a:noFill/>
+        </p:spPr>
+        <p:txBody>
+          <a:bodyPr wrap="square" lIns="0" tIns="0" rIns="0" bIns="0">
+            <a:spAutoFit/>
+          </a:bodyPr>
+          <a:lstStyle/>
+          <a:p>
+            <a:pPr>
+              <a:spcBef>
+                <a:spcPts val="0"/>
+              </a:spcBef>
+              <a:spcAft>
+                <a:spcPts val="800"/>
+              </a:spcAft>
+            </a:pPr>
+            <a:r>
+              <a:rPr sz="1350" dirty="0">
+                <a:solidFill>
+                  <a:srgbClr val="F26522"/>
+                </a:solidFill>
+                <a:latin typeface="Klavika Regular"/>
+              </a:rPr>
+              <a:t>•  </a:t>
+            </a:r>
+            <a:r>
+              <a:rPr sz="1350" dirty="0">
+                <a:solidFill>
+                  <a:srgbClr val="D8DADE"/>
+                </a:solidFill>
+                <a:latin typeface="Klavika Regular"/>
+              </a:rPr>
+              <a:t>Learning rate 2e-4: the size of each update. It warms up for 5 steps, then decays</a:t>
+            </a:r>
+          </a:p>
+          <a:p>
+            <a:pPr>
+              <a:spcBef>
+                <a:spcPts val="0"/>
+              </a:spcBef>
+              <a:spcAft>
+                <a:spcPts val="800"/>
+              </a:spcAft>
+            </a:pPr>
+            <a:r>
+              <a:rPr sz="1350" dirty="0">
+                <a:solidFill>
+                  <a:srgbClr val="F26522"/>
+                </a:solidFill>
+                <a:latin typeface="Klavika Regular"/>
+              </a:rPr>
+              <a:t>•  </a:t>
+            </a:r>
+            <a:r>
+              <a:rPr sz="1350" dirty="0">
+                <a:solidFill>
+                  <a:srgbClr val="D8DADE"/>
+                </a:solidFill>
+                <a:latin typeface="Klavika Regular"/>
+              </a:rPr>
+              <a:t>Batch of 8: 2 examples at a time, 4 accumulated per update</a:t>
+            </a:r>
+          </a:p>
+          <a:p>
+            <a:pPr>
+              <a:spcBef>
+                <a:spcPts val="0"/>
+              </a:spcBef>
+              <a:spcAft>
+                <a:spcPts val="800"/>
+              </a:spcAft>
+            </a:pPr>
+            <a:r>
+              <a:rPr sz="1350" dirty="0">
+                <a:solidFill>
+                  <a:srgbClr val="F26522"/>
+                </a:solidFill>
+                <a:latin typeface="Klavika Regular"/>
+              </a:rPr>
+              <a:t>•  </a:t>
+            </a:r>
+            <a:r>
+              <a:rPr sz="1350" dirty="0">
+                <a:solidFill>
+                  <a:srgbClr val="D8DADE"/>
+                </a:solidFill>
+                <a:latin typeface="Klavika Regular"/>
+              </a:rPr>
+              <a:t>LoRA rank 16: how much the adapter can learn</a:t>
+            </a:r>
+          </a:p>
+        </p:txBody>
+      </p:sp>
+      <p:sp>
+        <p:nvSpPr>
+          <p:cNvPr id="9" name="Rectangle 8"/>
+          <p:cNvSpPr/>
+          <p:nvPr/>
+        </p:nvSpPr>
+        <p:spPr>
+          <a:xfrm>
+            <a:off x="6254496" y="1920240"/>
+            <a:ext cx="5349240" cy="2331720"/>
+          </a:xfrm>
+          <a:prstGeom prst="rect">
+            <a:avLst/>
+          </a:prstGeom>
+          <a:solidFill>
+            <a:srgbClr val="1C1C1C"/>
+          </a:solidFill>
+          <a:ln w="9525">
+            <a:solidFill>
+              <a:srgbClr val="333333"/>
+            </a:solidFill>
+          </a:ln>
+          <a:effectLst/>
+        </p:spPr>
+        <p:style>
+          <a:lnRef idx="1">
+            <a:schemeClr val="accent1"/>
+          </a:lnRef>
+          <a:fillRef idx="3">
+            <a:schemeClr val="accent1"/>
+          </a:fillRef>
+          <a:effectRef idx="2">
+            <a:schemeClr val="accent1"/>
+          </a:effectRef>
+          <a:fontRef idx="minor">
+            <a:schemeClr val="lt1"/>
+          </a:fontRef>
+        </p:style>
+        <p:txBody>
+          <a:bodyPr rtlCol="0" anchor="ctr"/>
+          <a:lstStyle/>
+          <a:p>
+            <a:endParaRPr/>
+          </a:p>
+        </p:txBody>
+      </p:sp>
+      <p:sp>
+        <p:nvSpPr>
+          <p:cNvPr id="10" name="Rectangle 9"/>
+          <p:cNvSpPr/>
+          <p:nvPr/>
+        </p:nvSpPr>
+        <p:spPr>
+          <a:xfrm>
+            <a:off x="6254496" y="1920240"/>
+            <a:ext cx="5349240" cy="64008"/>
+          </a:xfrm>
+          <a:prstGeom prst="rect">
+            <a:avLst/>
+          </a:prstGeom>
+          <a:solidFill>
+            <a:srgbClr val="007C97"/>
+          </a:solidFill>
+          <a:ln>
+            <a:noFill/>
+          </a:ln>
+          <a:effectLst/>
+        </p:spPr>
+        <p:style>
+          <a:lnRef idx="1">
+            <a:schemeClr val="accent1"/>
+          </a:lnRef>
+          <a:fillRef idx="3">
+            <a:schemeClr val="accent1"/>
+          </a:fillRef>
+          <a:effectRef idx="2">
+            <a:schemeClr val="accent1"/>
+          </a:effectRef>
+          <a:fontRef idx="minor">
+            <a:schemeClr val="lt1"/>
+          </a:fontRef>
+        </p:style>
+        <p:txBody>
+          <a:bodyPr rtlCol="0" anchor="ctr"/>
+          <a:lstStyle/>
+          <a:p>
+            <a:pPr algn="ctr"/>
+            <a:endParaRPr/>
+          </a:p>
+        </p:txBody>
+      </p:sp>
+      <p:sp>
+        <p:nvSpPr>
+          <p:cNvPr id="11" name="Rounded Rectangle 10"/>
+          <p:cNvSpPr/>
+          <p:nvPr/>
+        </p:nvSpPr>
+        <p:spPr>
+          <a:xfrm>
+            <a:off x="6510528" y="2212848"/>
+            <a:ext cx="1051560" cy="274320"/>
+          </a:xfrm>
+          <a:prstGeom prst="roundRect">
+            <a:avLst/>
+          </a:prstGeom>
+          <a:solidFill>
+            <a:srgbClr val="007C97"/>
+          </a:solidFill>
+          <a:ln>
+            <a:noFill/>
+          </a:ln>
+          <a:effectLst/>
+        </p:spPr>
+        <p:style>
+          <a:lnRef idx="1">
+            <a:schemeClr val="accent1"/>
+          </a:lnRef>
+          <a:fillRef idx="3">
+            <a:schemeClr val="accent1"/>
+          </a:fillRef>
+          <a:effectRef idx="2">
+            <a:schemeClr val="accent1"/>
+          </a:effectRef>
+          <a:fontRef idx="minor">
+            <a:schemeClr val="lt1"/>
+          </a:fontRef>
+        </p:style>
+        <p:txBody>
+          <a:bodyPr wrap="none" lIns="0" tIns="0" rIns="0" bIns="0" rtlCol="0" anchor="ctr"/>
+          <a:lstStyle/>
+          <a:p>
+            <a:pPr algn="ctr"/>
+            <a:r>
+              <a:rPr sz="1100">
+                <a:solidFill>
+                  <a:srgbClr val="FFFFFF"/>
+                </a:solidFill>
+                <a:latin typeface="Klavika Bold"/>
+              </a:rPr>
+              <a:t>Loss</a:t>
+            </a:r>
+          </a:p>
+        </p:txBody>
+      </p:sp>
+      <p:sp>
+        <p:nvSpPr>
+          <p:cNvPr id="12" name="TextBox 11"/>
+          <p:cNvSpPr txBox="1"/>
+          <p:nvPr/>
+        </p:nvSpPr>
+        <p:spPr>
+          <a:xfrm>
+            <a:off x="7671816" y="2249424"/>
+            <a:ext cx="3611880" cy="256032"/>
+          </a:xfrm>
+          <a:prstGeom prst="rect">
+            <a:avLst/>
+          </a:prstGeom>
+          <a:noFill/>
+        </p:spPr>
+        <p:txBody>
+          <a:bodyPr wrap="square" lIns="0" tIns="0" rIns="0" bIns="0">
+            <a:spAutoFit/>
+          </a:bodyPr>
+          <a:lstStyle/>
+          <a:p>
+            <a:pPr algn="l">
+              <a:spcBef>
+                <a:spcPts val="0"/>
+              </a:spcBef>
+              <a:spcAft>
+                <a:spcPts val="600"/>
+              </a:spcAft>
+            </a:pPr>
+            <a:r>
+              <a:rPr sz="1400" b="0">
+                <a:solidFill>
+                  <a:srgbClr val="C6C8CC"/>
+                </a:solidFill>
+                <a:latin typeface="Klavika Medium"/>
+              </a:rPr>
+              <a:t>How wrong the next-token guesses are</a:t>
+            </a:r>
+          </a:p>
+        </p:txBody>
+      </p:sp>
+      <p:sp>
+        <p:nvSpPr>
+          <p:cNvPr id="13" name="TextBox 12"/>
+          <p:cNvSpPr txBox="1"/>
+          <p:nvPr/>
+        </p:nvSpPr>
+        <p:spPr>
+          <a:xfrm>
+            <a:off x="6510528" y="2697480"/>
+            <a:ext cx="4837176" cy="1417320"/>
+          </a:xfrm>
+          <a:prstGeom prst="rect">
+            <a:avLst/>
+          </a:prstGeom>
+          <a:noFill/>
+        </p:spPr>
+        <p:txBody>
+          <a:bodyPr wrap="square" lIns="0" tIns="0" rIns="0" bIns="0">
+            <a:spAutoFit/>
+          </a:bodyPr>
+          <a:lstStyle/>
+          <a:p>
+            <a:pPr>
+              <a:spcBef>
+                <a:spcPts val="0"/>
+              </a:spcBef>
+              <a:spcAft>
+                <a:spcPts val="800"/>
+              </a:spcAft>
+            </a:pPr>
+            <a:r>
+              <a:rPr sz="1350" dirty="0">
+                <a:solidFill>
+                  <a:srgbClr val="007C97"/>
+                </a:solidFill>
+                <a:latin typeface="Klavika Regular"/>
+              </a:rPr>
+              <a:t>•  </a:t>
+            </a:r>
+            <a:r>
+              <a:rPr sz="1350" dirty="0">
+                <a:solidFill>
+                  <a:srgbClr val="D8DADE"/>
+                </a:solidFill>
+                <a:latin typeface="Klavika Regular"/>
+              </a:rPr>
+              <a:t>Falls fast: the model is picking up the format</a:t>
+            </a:r>
+            <a:r>
+              <a:rPr sz="1350" dirty="0" err="1">
+                <a:solidFill>
+                  <a:srgbClr val="D8DADE"/>
+                </a:solidFill>
+                <a:latin typeface="Klavika Regular"/>
+              </a:rPr>
+              <a:t/>
+            </a:r>
+            <a:r>
+              <a:rPr sz="1350" dirty="0">
+                <a:solidFill>
+                  <a:srgbClr val="D8DADE"/>
+                </a:solidFill>
+                <a:latin typeface="Klavika Regular"/>
+              </a:rPr>
+              <a:t/>
+            </a:r>
+          </a:p>
+          <a:p>
+            <a:pPr>
+              <a:spcBef>
+                <a:spcPts val="0"/>
+              </a:spcBef>
+              <a:spcAft>
+                <a:spcPts val="800"/>
+              </a:spcAft>
+            </a:pPr>
+            <a:r>
+              <a:rPr sz="1350" dirty="0">
+                <a:solidFill>
+                  <a:srgbClr val="007C97"/>
+                </a:solidFill>
+                <a:latin typeface="Klavika Regular"/>
+              </a:rPr>
+              <a:t>•  </a:t>
+            </a:r>
+            <a:r>
+              <a:rPr sz="1350" dirty="0">
+                <a:solidFill>
+                  <a:srgbClr val="D8DADE"/>
+                </a:solidFill>
+                <a:latin typeface="Klavika Regular"/>
+              </a:rPr>
+              <a:t>Flat near zero: little left to learn from this data</a:t>
+            </a:r>
+            <a:r>
+              <a:rPr sz="1350" dirty="0" err="1">
+                <a:solidFill>
+                  <a:srgbClr val="D8DADE"/>
+                </a:solidFill>
+                <a:latin typeface="Klavika Regular"/>
+              </a:rPr>
+              <a:t/>
+            </a:r>
+            <a:r>
+              <a:rPr sz="1350" dirty="0">
+                <a:solidFill>
+                  <a:srgbClr val="D8DADE"/>
+                </a:solidFill>
+                <a:latin typeface="Klavika Regular"/>
+              </a:rPr>
+              <a:t/>
+            </a:r>
+          </a:p>
+          <a:p>
+            <a:pPr>
+              <a:spcBef>
+                <a:spcPts val="0"/>
+              </a:spcBef>
+              <a:spcAft>
+                <a:spcPts val="800"/>
+              </a:spcAft>
+            </a:pPr>
+            <a:r>
+              <a:rPr sz="1350" dirty="0">
+                <a:solidFill>
+                  <a:srgbClr val="007C97"/>
+                </a:solidFill>
+                <a:latin typeface="Klavika Regular"/>
+              </a:rPr>
+              <a:t>•  </a:t>
+            </a:r>
+            <a:r>
+              <a:rPr sz="1350" dirty="0">
+                <a:solidFill>
+                  <a:srgbClr val="D8DADE"/>
+                </a:solidFill>
+                <a:latin typeface="Klavika Regular"/>
+              </a:rPr>
+              <a:t>Only held-out tests show whether it generalizes or memorized</a:t>
+            </a:r>
+            <a:r>
+              <a:rPr sz="1350" dirty="0" err="1">
+                <a:solidFill>
+                  <a:srgbClr val="D8DADE"/>
+                </a:solidFill>
+                <a:latin typeface="Klavika Regular"/>
+              </a:rPr>
+              <a:t/>
+            </a:r>
+            <a:r>
+              <a:rPr sz="1350" dirty="0">
+                <a:solidFill>
+                  <a:srgbClr val="D8DADE"/>
+                </a:solidFill>
+                <a:latin typeface="Klavika Regular"/>
+              </a:rPr>
+              <a:t/>
+            </a:r>
+          </a:p>
+        </p:txBody>
+      </p:sp>
+      <p:sp>
+        <p:nvSpPr>
+          <p:cNvPr id="14" name="Rectangle 13"/>
+          <p:cNvSpPr/>
+          <p:nvPr/>
+        </p:nvSpPr>
+        <p:spPr>
+          <a:xfrm>
+            <a:off x="585216" y="4572000"/>
+            <a:ext cx="3489960" cy="1188720"/>
+          </a:xfrm>
+          <a:prstGeom prst="rect">
+            <a:avLst/>
+          </a:prstGeom>
+          <a:solidFill>
+            <a:srgbClr val="151515"/>
+          </a:solidFill>
+          <a:ln w="9525">
+            <a:solidFill>
+              <a:srgbClr val="333333"/>
+            </a:solidFill>
+          </a:ln>
+          <a:effectLst/>
+        </p:spPr>
+        <p:style>
+          <a:lnRef idx="1">
+            <a:schemeClr val="accent1"/>
+          </a:lnRef>
+          <a:fillRef idx="3">
+            <a:schemeClr val="accent1"/>
+          </a:fillRef>
+          <a:effectRef idx="2">
+            <a:schemeClr val="accent1"/>
+          </a:effectRef>
+          <a:fontRef idx="minor">
+            <a:schemeClr val="lt1"/>
+          </a:fontRef>
+        </p:style>
+        <p:txBody>
+          <a:bodyPr rtlCol="0" anchor="ctr"/>
+          <a:lstStyle/>
+          <a:p>
+            <a:endParaRPr/>
+          </a:p>
+        </p:txBody>
+      </p:sp>
+      <p:sp>
+        <p:nvSpPr>
+          <p:cNvPr id="15" name="Rectangle 14"/>
+          <p:cNvSpPr/>
+          <p:nvPr/>
+        </p:nvSpPr>
+        <p:spPr>
+          <a:xfrm>
+            <a:off x="585216" y="4572000"/>
+            <a:ext cx="64008" cy="1188720"/>
+          </a:xfrm>
+          <a:prstGeom prst="rect">
+            <a:avLst/>
+          </a:prstGeom>
+          <a:solidFill>
+            <a:srgbClr val="F26522"/>
+          </a:solidFill>
+          <a:ln>
+            <a:noFill/>
+          </a:ln>
+          <a:effectLst/>
+        </p:spPr>
+        <p:style>
+          <a:lnRef idx="1">
+            <a:schemeClr val="accent1"/>
+          </a:lnRef>
+          <a:fillRef idx="3">
+            <a:schemeClr val="accent1"/>
+          </a:fillRef>
+          <a:effectRef idx="2">
+            <a:schemeClr val="accent1"/>
+          </a:effectRef>
+          <a:fontRef idx="minor">
+            <a:schemeClr val="lt1"/>
+          </a:fontRef>
+        </p:style>
+        <p:txBody>
+          <a:bodyPr rtlCol="0" anchor="ctr"/>
+          <a:lstStyle/>
+          <a:p>
+            <a:pPr algn="ctr"/>
+            <a:endParaRPr/>
+          </a:p>
+        </p:txBody>
+      </p:sp>
+      <p:sp>
+        <p:nvSpPr>
+          <p:cNvPr id="16" name="TextBox 15"/>
+          <p:cNvSpPr txBox="1"/>
+          <p:nvPr/>
+        </p:nvSpPr>
+        <p:spPr>
+          <a:xfrm>
+            <a:off x="859536" y="4773168"/>
+            <a:ext cx="2941320" cy="475488"/>
+          </a:xfrm>
+          <a:prstGeom prst="rect">
+            <a:avLst/>
+          </a:prstGeom>
+          <a:noFill/>
+        </p:spPr>
+        <p:txBody>
+          <a:bodyPr wrap="square" lIns="0" tIns="0" rIns="0" bIns="0">
+            <a:spAutoFit/>
+          </a:bodyPr>
+          <a:lstStyle/>
+          <a:p>
+            <a:pPr algn="l">
+              <a:spcBef>
+                <a:spcPts val="0"/>
+              </a:spcBef>
+              <a:spcAft>
+                <a:spcPts val="600"/>
+              </a:spcAft>
+            </a:pPr>
+            <a:r>
+              <a:rPr sz="2600" b="0">
+                <a:solidFill>
+                  <a:srgbClr val="F26522"/>
+                </a:solidFill>
+                <a:latin typeface="Klavika Bold"/>
+              </a:rPr>
+              <a:t>240</a:t>
+            </a:r>
+          </a:p>
+        </p:txBody>
+      </p:sp>
+      <p:sp>
+        <p:nvSpPr>
+          <p:cNvPr id="17" name="TextBox 16"/>
+          <p:cNvSpPr txBox="1"/>
+          <p:nvPr/>
+        </p:nvSpPr>
+        <p:spPr>
+          <a:xfrm>
+            <a:off x="859536" y="5321808"/>
+            <a:ext cx="2941320" cy="310896"/>
+          </a:xfrm>
+          <a:prstGeom prst="rect">
+            <a:avLst/>
+          </a:prstGeom>
+          <a:noFill/>
+        </p:spPr>
+        <p:txBody>
+          <a:bodyPr wrap="square" lIns="0" tIns="0" rIns="0" bIns="0">
+            <a:spAutoFit/>
+          </a:bodyPr>
+          <a:lstStyle/>
+          <a:p>
+            <a:pPr algn="l">
+              <a:spcBef>
+                <a:spcPts val="0"/>
+              </a:spcBef>
+              <a:spcAft>
+                <a:spcPts val="600"/>
+              </a:spcAft>
+            </a:pPr>
+            <a:r>
+              <a:rPr sz="1300" b="0">
+                <a:solidFill>
+                  <a:srgbClr val="D8DADE"/>
+                </a:solidFill>
+                <a:latin typeface="Klavika Regular"/>
+              </a:rPr>
+              <a:t>examples seen in 30 steps</a:t>
+            </a:r>
+          </a:p>
+        </p:txBody>
+      </p:sp>
+      <p:sp>
+        <p:nvSpPr>
+          <p:cNvPr id="18" name="Rectangle 17"/>
+          <p:cNvSpPr/>
+          <p:nvPr/>
+        </p:nvSpPr>
+        <p:spPr>
+          <a:xfrm>
+            <a:off x="4349496" y="4572000"/>
+            <a:ext cx="3489960" cy="1188720"/>
+          </a:xfrm>
+          <a:prstGeom prst="rect">
+            <a:avLst/>
+          </a:prstGeom>
+          <a:solidFill>
+            <a:srgbClr val="151515"/>
+          </a:solidFill>
+          <a:ln w="9525">
+            <a:solidFill>
+              <a:srgbClr val="333333"/>
+            </a:solidFill>
+          </a:ln>
+          <a:effectLst/>
+        </p:spPr>
+        <p:style>
+          <a:lnRef idx="1">
+            <a:schemeClr val="accent1"/>
+          </a:lnRef>
+          <a:fillRef idx="3">
+            <a:schemeClr val="accent1"/>
+          </a:fillRef>
+          <a:effectRef idx="2">
+            <a:schemeClr val="accent1"/>
+          </a:effectRef>
+          <a:fontRef idx="minor">
+            <a:schemeClr val="lt1"/>
+          </a:fontRef>
+        </p:style>
+        <p:txBody>
+          <a:bodyPr rtlCol="0" anchor="ctr"/>
+          <a:lstStyle/>
+          <a:p>
+            <a:endParaRPr/>
+          </a:p>
+        </p:txBody>
+      </p:sp>
+      <p:sp>
+        <p:nvSpPr>
+          <p:cNvPr id="19" name="Rectangle 18"/>
+          <p:cNvSpPr/>
+          <p:nvPr/>
+        </p:nvSpPr>
+        <p:spPr>
+          <a:xfrm>
+            <a:off x="4349496" y="4572000"/>
+            <a:ext cx="64008" cy="1188720"/>
+          </a:xfrm>
+          <a:prstGeom prst="rect">
+            <a:avLst/>
+          </a:prstGeom>
+          <a:solidFill>
+            <a:srgbClr val="007C97"/>
+          </a:solidFill>
+          <a:ln>
+            <a:noFill/>
+          </a:ln>
+          <a:effectLst/>
+        </p:spPr>
+        <p:style>
+          <a:lnRef idx="1">
+            <a:schemeClr val="accent1"/>
+          </a:lnRef>
+          <a:fillRef idx="3">
+            <a:schemeClr val="accent1"/>
+          </a:fillRef>
+          <a:effectRef idx="2">
+            <a:schemeClr val="accent1"/>
+          </a:effectRef>
+          <a:fontRef idx="minor">
+            <a:schemeClr val="lt1"/>
+          </a:fontRef>
+        </p:style>
+        <p:txBody>
+          <a:bodyPr rtlCol="0" anchor="ctr"/>
+          <a:lstStyle/>
+          <a:p>
+            <a:pPr algn="ctr"/>
+            <a:endParaRPr/>
+          </a:p>
+        </p:txBody>
+      </p:sp>
+      <p:sp>
+        <p:nvSpPr>
+          <p:cNvPr id="20" name="TextBox 19"/>
+          <p:cNvSpPr txBox="1"/>
+          <p:nvPr/>
+        </p:nvSpPr>
+        <p:spPr>
+          <a:xfrm>
+            <a:off x="4623816" y="4773168"/>
+            <a:ext cx="2941320" cy="475488"/>
+          </a:xfrm>
+          <a:prstGeom prst="rect">
+            <a:avLst/>
+          </a:prstGeom>
+          <a:noFill/>
+        </p:spPr>
+        <p:txBody>
+          <a:bodyPr wrap="square" lIns="0" tIns="0" rIns="0" bIns="0">
+            <a:spAutoFit/>
+          </a:bodyPr>
+          <a:lstStyle/>
+          <a:p>
+            <a:pPr algn="l">
+              <a:spcBef>
+                <a:spcPts val="0"/>
+              </a:spcBef>
+              <a:spcAft>
+                <a:spcPts val="600"/>
+              </a:spcAft>
+            </a:pPr>
+            <a:r>
+              <a:rPr sz="2600" b="0">
+                <a:solidFill>
+                  <a:srgbClr val="007C97"/>
+                </a:solidFill>
+                <a:latin typeface="Klavika Bold"/>
+              </a:rPr>
+              <a:t>~1%</a:t>
+            </a:r>
+          </a:p>
+        </p:txBody>
+      </p:sp>
+      <p:sp>
+        <p:nvSpPr>
+          <p:cNvPr id="21" name="TextBox 20"/>
+          <p:cNvSpPr txBox="1"/>
+          <p:nvPr/>
+        </p:nvSpPr>
+        <p:spPr>
+          <a:xfrm>
+            <a:off x="4623816" y="5321808"/>
+            <a:ext cx="2941320" cy="310896"/>
+          </a:xfrm>
+          <a:prstGeom prst="rect">
+            <a:avLst/>
+          </a:prstGeom>
+          <a:noFill/>
+        </p:spPr>
+        <p:txBody>
+          <a:bodyPr wrap="square" lIns="0" tIns="0" rIns="0" bIns="0">
+            <a:spAutoFit/>
+          </a:bodyPr>
+          <a:lstStyle/>
+          <a:p>
+            <a:pPr algn="l">
+              <a:spcBef>
+                <a:spcPts val="0"/>
+              </a:spcBef>
+              <a:spcAft>
+                <a:spcPts val="600"/>
+              </a:spcAft>
+            </a:pPr>
+            <a:r>
+              <a:rPr sz="1300" b="0">
+                <a:solidFill>
+                  <a:srgbClr val="D8DADE"/>
+                </a:solidFill>
+                <a:latin typeface="Klavika Regular"/>
+              </a:rPr>
+              <a:t>of the weights trained (23M)</a:t>
+            </a:r>
+          </a:p>
+        </p:txBody>
+      </p:sp>
+      <p:sp>
+        <p:nvSpPr>
+          <p:cNvPr id="22" name="Rectangle 21"/>
+          <p:cNvSpPr/>
+          <p:nvPr/>
+        </p:nvSpPr>
+        <p:spPr>
+          <a:xfrm>
+            <a:off x="8113776" y="4572000"/>
+            <a:ext cx="3489960" cy="1188720"/>
+          </a:xfrm>
+          <a:prstGeom prst="rect">
+            <a:avLst/>
+          </a:prstGeom>
+          <a:solidFill>
+            <a:srgbClr val="151515"/>
+          </a:solidFill>
+          <a:ln w="9525">
+            <a:solidFill>
+              <a:srgbClr val="333333"/>
+            </a:solidFill>
+          </a:ln>
+          <a:effectLst/>
+        </p:spPr>
+        <p:style>
+          <a:lnRef idx="1">
+            <a:schemeClr val="accent1"/>
+          </a:lnRef>
+          <a:fillRef idx="3">
+            <a:schemeClr val="accent1"/>
+          </a:fillRef>
+          <a:effectRef idx="2">
+            <a:schemeClr val="accent1"/>
+          </a:effectRef>
+          <a:fontRef idx="minor">
+            <a:schemeClr val="lt1"/>
+          </a:fontRef>
+        </p:style>
+        <p:txBody>
+          <a:bodyPr rtlCol="0" anchor="ctr"/>
+          <a:lstStyle/>
+          <a:p>
+            <a:endParaRPr/>
+          </a:p>
+        </p:txBody>
+      </p:sp>
+      <p:sp>
+        <p:nvSpPr>
+          <p:cNvPr id="23" name="Rectangle 22"/>
+          <p:cNvSpPr/>
+          <p:nvPr/>
+        </p:nvSpPr>
+        <p:spPr>
+          <a:xfrm>
+            <a:off x="8113776" y="4572000"/>
+            <a:ext cx="64008" cy="1188720"/>
+          </a:xfrm>
+          <a:prstGeom prst="rect">
+            <a:avLst/>
+          </a:prstGeom>
+          <a:solidFill>
+            <a:srgbClr val="ED1C24"/>
+          </a:solidFill>
+          <a:ln>
+            <a:noFill/>
+          </a:ln>
+          <a:effectLst/>
+        </p:spPr>
+        <p:style>
+          <a:lnRef idx="1">
+            <a:schemeClr val="accent1"/>
+          </a:lnRef>
+          <a:fillRef idx="3">
+            <a:schemeClr val="accent1"/>
+          </a:fillRef>
+          <a:effectRef idx="2">
+            <a:schemeClr val="accent1"/>
+          </a:effectRef>
+          <a:fontRef idx="minor">
+            <a:schemeClr val="lt1"/>
+          </a:fontRef>
+        </p:style>
+        <p:txBody>
+          <a:bodyPr rtlCol="0" anchor="ctr"/>
+          <a:lstStyle/>
+          <a:p>
+            <a:pPr algn="ctr"/>
+            <a:endParaRPr/>
+          </a:p>
+        </p:txBody>
+      </p:sp>
+      <p:sp>
+        <p:nvSpPr>
+          <p:cNvPr id="24" name="TextBox 23"/>
+          <p:cNvSpPr txBox="1"/>
+          <p:nvPr/>
+        </p:nvSpPr>
+        <p:spPr>
+          <a:xfrm>
+            <a:off x="8388096" y="4773168"/>
+            <a:ext cx="2941320" cy="475488"/>
+          </a:xfrm>
+          <a:prstGeom prst="rect">
+            <a:avLst/>
+          </a:prstGeom>
+          <a:noFill/>
+        </p:spPr>
+        <p:txBody>
+          <a:bodyPr wrap="square" lIns="0" tIns="0" rIns="0" bIns="0">
+            <a:spAutoFit/>
+          </a:bodyPr>
+          <a:lstStyle/>
+          <a:p>
+            <a:pPr algn="l">
+              <a:spcBef>
+                <a:spcPts val="0"/>
+              </a:spcBef>
+              <a:spcAft>
+                <a:spcPts val="600"/>
+              </a:spcAft>
+            </a:pPr>
+            <a:r>
+              <a:rPr sz="2600" b="0">
+                <a:solidFill>
+                  <a:srgbClr val="ED1C24"/>
+                </a:solidFill>
+                <a:latin typeface="Klavika Bold"/>
+              </a:rPr>
+              <a:t>~4 min</a:t>
+            </a:r>
+          </a:p>
+        </p:txBody>
+      </p:sp>
+      <p:sp>
+        <p:nvSpPr>
+          <p:cNvPr id="25" name="TextBox 24"/>
+          <p:cNvSpPr txBox="1"/>
+          <p:nvPr/>
+        </p:nvSpPr>
+        <p:spPr>
+          <a:xfrm>
+            <a:off x="8388096" y="5321808"/>
+            <a:ext cx="2941320" cy="310896"/>
+          </a:xfrm>
+          <a:prstGeom prst="rect">
+            <a:avLst/>
+          </a:prstGeom>
+          <a:noFill/>
+        </p:spPr>
+        <p:txBody>
+          <a:bodyPr wrap="square" lIns="0" tIns="0" rIns="0" bIns="0">
+            <a:spAutoFit/>
+          </a:bodyPr>
+          <a:lstStyle/>
+          <a:p>
+            <a:pPr algn="l">
+              <a:spcBef>
+                <a:spcPts val="0"/>
+              </a:spcBef>
+              <a:spcAft>
+                <a:spcPts val="600"/>
+              </a:spcAft>
+            </a:pPr>
+            <a:r>
+              <a:rPr sz="1300" b="0" dirty="0">
+                <a:solidFill>
+                  <a:srgbClr val="D8DADE"/>
+                </a:solidFill>
+                <a:latin typeface="Klavika Regular"/>
+              </a:rPr>
+              <a:t>for 30 steps on a Ryzen AI Max+</a:t>
+            </a:r>
+          </a:p>
+        </p:txBody>
+      </p:sp>
+    </p:spTree>
+  </p:cSld>
+  <p:clrMapOvr>
+    <a:masterClrMapping/>
+  </p:clrMapOvr>
+</p:sld>
+</file>
+
+<file path=ppt/slides/slide22.xml><?xml version="1.0" encoding="utf-8"?>
+<p:sld xmlns:a="http://schemas.openxmlformats.org/drawingml/2006/main" xmlns:p="http://schemas.openxmlformats.org/presentationml/2006/main" xmlns:r="http://schemas.openxmlformats.org/officeDocument/2006/relationships">
+  <p:cSld>
+    <p:bg>
+      <p:bgPr>
+        <a:blipFill rotWithShape="1">
+          <a:blip r:embed="rId2"/>
+          <a:stretch>
+            <a:fillRect/>
+          </a:stretch>
+        </a:blipFill>
+        <a:effectLst/>
+      </p:bgPr>
+    </p:bg>
+    <p:spTree>
+      <p:nvGrpSpPr>
+        <p:cNvPr id="1" name=""/>
+        <p:cNvGrpSpPr/>
+        <p:nvPr/>
+      </p:nvGrpSpPr>
+      <p:grpSpPr>
+        <a:xfrm>
+          <a:off x="0" y="0"/>
+          <a:ext cx="0" cy="0"/>
+          <a:chOff x="0" y="0"/>
+          <a:chExt cx="0" cy="0"/>
+        </a:xfrm>
+      </p:grpSpPr>
+      <p:sp>
+        <p:nvSpPr>
+          <p:cNvPr id="2" name="Title 1"/>
+          <p:cNvSpPr>
+            <a:spLocks noGrp="1"/>
+          </p:cNvSpPr>
+          <p:nvPr>
+            <p:ph type="title"/>
+          </p:nvPr>
+        </p:nvSpPr>
+        <p:spPr/>
+        <p:txBody>
+          <a:bodyPr/>
+          <a:lstStyle/>
+          <a:p>
+            <a:r>
+              <a:rPr sz="3200" b="0">
+                <a:solidFill>
+                  <a:srgbClr val="FFFFFF"/>
+                </a:solidFill>
+                <a:latin typeface="Klavika Bold"/>
+              </a:rPr>
+              <a:t>Finished early? Stretch challenges</a:t>
+            </a:r>
+          </a:p>
+        </p:txBody>
+      </p:sp>
+      <p:sp>
+        <p:nvSpPr>
+          <p:cNvPr id="3" name="TextBox 2"/>
+          <p:cNvSpPr txBox="1"/>
+          <p:nvPr/>
+        </p:nvSpPr>
+        <p:spPr>
+          <a:xfrm>
+            <a:off x="859536" y="1060704"/>
+            <a:ext cx="3657600" cy="237744"/>
+          </a:xfrm>
+          <a:prstGeom prst="rect">
+            <a:avLst/>
+          </a:prstGeom>
+          <a:noFill/>
+        </p:spPr>
+        <p:txBody>
+          <a:bodyPr wrap="square" lIns="0" tIns="0" rIns="0" bIns="0">
+            <a:spAutoFit/>
+          </a:bodyPr>
+          <a:lstStyle/>
+          <a:p>
+            <a:pPr algn="l">
+              <a:spcBef>
+                <a:spcPts val="0"/>
+              </a:spcBef>
+              <a:spcAft>
+                <a:spcPts val="600"/>
+              </a:spcAft>
+            </a:pPr>
+            <a:r>
+              <a:rPr sz="1100" b="0">
+                <a:solidFill>
+                  <a:srgbClr val="C6C8CC"/>
+                </a:solidFill>
+                <a:latin typeface="Klavika Bold"/>
+              </a:rPr>
+              <a:t>CHALLENGE</a:t>
+            </a:r>
+          </a:p>
+        </p:txBody>
+      </p:sp>
+      <p:sp>
+        <p:nvSpPr>
+          <p:cNvPr id="4" name="TextBox 3"/>
+          <p:cNvSpPr txBox="1"/>
+          <p:nvPr/>
+        </p:nvSpPr>
+        <p:spPr>
+          <a:xfrm>
+            <a:off x="5065776" y="1060704"/>
+            <a:ext cx="3657600" cy="237744"/>
+          </a:xfrm>
+          <a:prstGeom prst="rect">
+            <a:avLst/>
+          </a:prstGeom>
+          <a:noFill/>
+        </p:spPr>
+        <p:txBody>
+          <a:bodyPr wrap="square" lIns="0" tIns="0" rIns="0" bIns="0">
+            <a:spAutoFit/>
+          </a:bodyPr>
+          <a:lstStyle/>
+          <a:p>
+            <a:pPr algn="l">
+              <a:spcBef>
+                <a:spcPts val="0"/>
+              </a:spcBef>
+              <a:spcAft>
+                <a:spcPts val="600"/>
+              </a:spcAft>
+            </a:pPr>
+            <a:r>
+              <a:rPr sz="1100" b="0">
+                <a:solidFill>
+                  <a:srgbClr val="C6C8CC"/>
+                </a:solidFill>
+                <a:latin typeface="Klavika Bold"/>
+              </a:rPr>
+              <a:t>HOW</a:t>
+            </a:r>
+          </a:p>
+        </p:txBody>
+      </p:sp>
+      <p:sp>
+        <p:nvSpPr>
+          <p:cNvPr id="5" name="Rectangle 4"/>
+          <p:cNvSpPr/>
+          <p:nvPr/>
+        </p:nvSpPr>
+        <p:spPr>
+          <a:xfrm>
+            <a:off x="585216" y="1353312"/>
+            <a:ext cx="11018520" cy="658368"/>
+          </a:xfrm>
+          <a:prstGeom prst="rect">
+            <a:avLst/>
+          </a:prstGeom>
+          <a:solidFill>
+            <a:srgbClr val="151515"/>
+          </a:solidFill>
+          <a:ln w="9525">
+            <a:solidFill>
+              <a:srgbClr val="333333"/>
+            </a:solidFill>
+          </a:ln>
+          <a:effectLst/>
+        </p:spPr>
+        <p:style>
+          <a:lnRef idx="1">
+            <a:schemeClr val="accent1"/>
+          </a:lnRef>
+          <a:fillRef idx="3">
+            <a:schemeClr val="accent1"/>
+          </a:fillRef>
+          <a:effectRef idx="2">
+            <a:schemeClr val="accent1"/>
+          </a:effectRef>
+          <a:fontRef idx="minor">
+            <a:schemeClr val="lt1"/>
+          </a:fontRef>
+        </p:style>
+        <p:txBody>
+          <a:bodyPr rtlCol="0" anchor="ctr"/>
+          <a:lstStyle/>
+          <a:p>
+            <a:endParaRPr/>
+          </a:p>
+        </p:txBody>
+      </p:sp>
+      <p:sp>
+        <p:nvSpPr>
+          <p:cNvPr id="6" name="Rectangle 5"/>
+          <p:cNvSpPr/>
+          <p:nvPr/>
+        </p:nvSpPr>
+        <p:spPr>
+          <a:xfrm>
+            <a:off x="585216" y="1353312"/>
+            <a:ext cx="64008" cy="658368"/>
+          </a:xfrm>
+          <a:prstGeom prst="rect">
+            <a:avLst/>
+          </a:prstGeom>
+          <a:solidFill>
+            <a:srgbClr val="F26522"/>
+          </a:solidFill>
+          <a:ln>
+            <a:noFill/>
+          </a:ln>
+          <a:effectLst/>
+        </p:spPr>
+        <p:style>
+          <a:lnRef idx="1">
+            <a:schemeClr val="accent1"/>
+          </a:lnRef>
+          <a:fillRef idx="3">
+            <a:schemeClr val="accent1"/>
+          </a:fillRef>
+          <a:effectRef idx="2">
+            <a:schemeClr val="accent1"/>
+          </a:effectRef>
+          <a:fontRef idx="minor">
+            <a:schemeClr val="lt1"/>
+          </a:fontRef>
+        </p:style>
+        <p:txBody>
+          <a:bodyPr rtlCol="0" anchor="ctr"/>
+          <a:lstStyle/>
+          <a:p>
+            <a:pPr algn="ctr"/>
+            <a:endParaRPr/>
+          </a:p>
+        </p:txBody>
+      </p:sp>
+      <p:sp>
+        <p:nvSpPr>
+          <p:cNvPr id="7" name="TextBox 6"/>
+          <p:cNvSpPr txBox="1"/>
+          <p:nvPr/>
+        </p:nvSpPr>
+        <p:spPr>
+          <a:xfrm>
+            <a:off x="859536" y="1554480"/>
+            <a:ext cx="3977639" cy="292608"/>
+          </a:xfrm>
+          <a:prstGeom prst="rect">
+            <a:avLst/>
+          </a:prstGeom>
+          <a:noFill/>
+        </p:spPr>
+        <p:txBody>
+          <a:bodyPr wrap="square" lIns="0" tIns="0" rIns="0" bIns="0">
+            <a:spAutoFit/>
+          </a:bodyPr>
+          <a:lstStyle/>
+          <a:p>
+            <a:pPr algn="l">
+              <a:spcBef>
+                <a:spcPts val="0"/>
+              </a:spcBef>
+              <a:spcAft>
+                <a:spcPts val="600"/>
+              </a:spcAft>
+            </a:pPr>
+            <a:r>
+              <a:rPr sz="1350" b="0">
+                <a:solidFill>
+                  <a:srgbClr val="FFFFFF"/>
+                </a:solidFill>
+                <a:latin typeface="Klavika Bold"/>
+              </a:rPr>
+              <a:t>Add a field</a:t>
+            </a:r>
+          </a:p>
+        </p:txBody>
+      </p:sp>
+      <p:sp>
+        <p:nvSpPr>
+          <p:cNvPr id="8" name="TextBox 7"/>
+          <p:cNvSpPr txBox="1"/>
+          <p:nvPr/>
+        </p:nvSpPr>
+        <p:spPr>
+          <a:xfrm>
+            <a:off x="5065776" y="1554480"/>
+            <a:ext cx="6263640" cy="292608"/>
+          </a:xfrm>
+          <a:prstGeom prst="rect">
+            <a:avLst/>
+          </a:prstGeom>
+          <a:noFill/>
+        </p:spPr>
+        <p:txBody>
+          <a:bodyPr wrap="square" lIns="0" tIns="0" rIns="0" bIns="0">
+            <a:spAutoFit/>
+          </a:bodyPr>
+          <a:lstStyle/>
+          <a:p>
+            <a:pPr algn="l">
+              <a:spcBef>
+                <a:spcPts val="0"/>
+              </a:spcBef>
+              <a:spcAft>
+                <a:spcPts val="600"/>
+              </a:spcAft>
+            </a:pPr>
+            <a:r>
+              <a:rPr sz="1300" b="0">
+                <a:solidFill>
+                  <a:srgbClr val="D8DADE"/>
+                </a:solidFill>
+                <a:latin typeface="Klavika Regular"/>
+              </a:rPr>
+              <a:t>Add priority (urgent when the message says ASAP) to the data generator and the scorer's FIELDS, then retrain.</a:t>
+            </a:r>
+          </a:p>
+        </p:txBody>
+      </p:sp>
+      <p:sp>
+        <p:nvSpPr>
+          <p:cNvPr id="9" name="Rectangle 8"/>
+          <p:cNvSpPr/>
+          <p:nvPr/>
+        </p:nvSpPr>
+        <p:spPr>
+          <a:xfrm>
+            <a:off x="585216" y="2157984"/>
+            <a:ext cx="11018520" cy="658368"/>
+          </a:xfrm>
+          <a:prstGeom prst="rect">
+            <a:avLst/>
+          </a:prstGeom>
+          <a:solidFill>
+            <a:srgbClr val="151515"/>
+          </a:solidFill>
+          <a:ln w="9525">
+            <a:solidFill>
+              <a:srgbClr val="333333"/>
+            </a:solidFill>
+          </a:ln>
+          <a:effectLst/>
+        </p:spPr>
+        <p:style>
+          <a:lnRef idx="1">
+            <a:schemeClr val="accent1"/>
+          </a:lnRef>
+          <a:fillRef idx="3">
+            <a:schemeClr val="accent1"/>
+          </a:fillRef>
+          <a:effectRef idx="2">
+            <a:schemeClr val="accent1"/>
+          </a:effectRef>
+          <a:fontRef idx="minor">
+            <a:schemeClr val="lt1"/>
+          </a:fontRef>
+        </p:style>
+        <p:txBody>
+          <a:bodyPr rtlCol="0" anchor="ctr"/>
+          <a:lstStyle/>
+          <a:p>
+            <a:endParaRPr/>
+          </a:p>
+        </p:txBody>
+      </p:sp>
+      <p:sp>
+        <p:nvSpPr>
+          <p:cNvPr id="10" name="Rectangle 9"/>
+          <p:cNvSpPr/>
+          <p:nvPr/>
+        </p:nvSpPr>
+        <p:spPr>
+          <a:xfrm>
+            <a:off x="585216" y="2157984"/>
+            <a:ext cx="64008" cy="658368"/>
+          </a:xfrm>
+          <a:prstGeom prst="rect">
+            <a:avLst/>
+          </a:prstGeom>
+          <a:solidFill>
+            <a:srgbClr val="007C97"/>
+          </a:solidFill>
+          <a:ln>
+            <a:noFill/>
+          </a:ln>
+          <a:effectLst/>
+        </p:spPr>
+        <p:style>
+          <a:lnRef idx="1">
+            <a:schemeClr val="accent1"/>
+          </a:lnRef>
+          <a:fillRef idx="3">
+            <a:schemeClr val="accent1"/>
+          </a:fillRef>
+          <a:effectRef idx="2">
+            <a:schemeClr val="accent1"/>
+          </a:effectRef>
+          <a:fontRef idx="minor">
+            <a:schemeClr val="lt1"/>
+          </a:fontRef>
+        </p:style>
+        <p:txBody>
+          <a:bodyPr rtlCol="0" anchor="ctr"/>
+          <a:lstStyle/>
+          <a:p>
+            <a:pPr algn="ctr"/>
+            <a:endParaRPr/>
+          </a:p>
+        </p:txBody>
+      </p:sp>
+      <p:sp>
+        <p:nvSpPr>
+          <p:cNvPr id="11" name="TextBox 10"/>
+          <p:cNvSpPr txBox="1"/>
+          <p:nvPr/>
+        </p:nvSpPr>
+        <p:spPr>
+          <a:xfrm>
+            <a:off x="859536" y="2359152"/>
+            <a:ext cx="3977639" cy="292608"/>
+          </a:xfrm>
+          <a:prstGeom prst="rect">
+            <a:avLst/>
+          </a:prstGeom>
+          <a:noFill/>
+        </p:spPr>
+        <p:txBody>
+          <a:bodyPr wrap="square" lIns="0" tIns="0" rIns="0" bIns="0">
+            <a:spAutoFit/>
+          </a:bodyPr>
+          <a:lstStyle/>
+          <a:p>
+            <a:pPr algn="l">
+              <a:spcBef>
+                <a:spcPts val="0"/>
+              </a:spcBef>
+              <a:spcAft>
+                <a:spcPts val="600"/>
+              </a:spcAft>
+            </a:pPr>
+            <a:r>
+              <a:rPr sz="1350" b="0">
+                <a:solidFill>
+                  <a:srgbClr val="FFFFFF"/>
+                </a:solidFill>
+                <a:latin typeface="Klavika Bold"/>
+              </a:rPr>
+              <a:t>Teach it your own task</a:t>
+            </a:r>
+          </a:p>
+        </p:txBody>
+      </p:sp>
+      <p:sp>
+        <p:nvSpPr>
+          <p:cNvPr id="12" name="TextBox 11"/>
+          <p:cNvSpPr txBox="1"/>
+          <p:nvPr/>
+        </p:nvSpPr>
+        <p:spPr>
+          <a:xfrm>
+            <a:off x="5065776" y="2359152"/>
+            <a:ext cx="6263640" cy="292608"/>
+          </a:xfrm>
+          <a:prstGeom prst="rect">
+            <a:avLst/>
+          </a:prstGeom>
+          <a:noFill/>
+        </p:spPr>
+        <p:txBody>
+          <a:bodyPr wrap="square" lIns="0" tIns="0" rIns="0" bIns="0">
+            <a:spAutoFit/>
+          </a:bodyPr>
+          <a:lstStyle/>
+          <a:p>
+            <a:pPr algn="l">
+              <a:spcBef>
+                <a:spcPts val="0"/>
+              </a:spcBef>
+              <a:spcAft>
+                <a:spcPts val="600"/>
+              </a:spcAft>
+            </a:pPr>
+            <a:r>
+              <a:rPr sz="1300" b="0">
+                <a:solidFill>
+                  <a:srgbClr val="D8DADE"/>
+                </a:solidFill>
+                <a:latin typeface="Klavika Regular"/>
+              </a:rPr>
+              <a:t>Write 5 examples by hand, let a bigger model write 50 more, train 30 steps. Ideas on the next slide.</a:t>
+            </a:r>
+          </a:p>
+        </p:txBody>
+      </p:sp>
+      <p:sp>
+        <p:nvSpPr>
+          <p:cNvPr id="13" name="Rectangle 12"/>
+          <p:cNvSpPr/>
+          <p:nvPr/>
+        </p:nvSpPr>
+        <p:spPr>
+          <a:xfrm>
+            <a:off x="585216" y="2962656"/>
+            <a:ext cx="11018520" cy="658368"/>
+          </a:xfrm>
+          <a:prstGeom prst="rect">
+            <a:avLst/>
+          </a:prstGeom>
+          <a:solidFill>
+            <a:srgbClr val="151515"/>
+          </a:solidFill>
+          <a:ln w="9525">
+            <a:solidFill>
+              <a:srgbClr val="333333"/>
+            </a:solidFill>
+          </a:ln>
+          <a:effectLst/>
+        </p:spPr>
+        <p:style>
+          <a:lnRef idx="1">
+            <a:schemeClr val="accent1"/>
+          </a:lnRef>
+          <a:fillRef idx="3">
+            <a:schemeClr val="accent1"/>
+          </a:fillRef>
+          <a:effectRef idx="2">
+            <a:schemeClr val="accent1"/>
+          </a:effectRef>
+          <a:fontRef idx="minor">
+            <a:schemeClr val="lt1"/>
+          </a:fontRef>
+        </p:style>
+        <p:txBody>
+          <a:bodyPr rtlCol="0" anchor="ctr"/>
+          <a:lstStyle/>
+          <a:p>
+            <a:endParaRPr/>
+          </a:p>
+        </p:txBody>
+      </p:sp>
+      <p:sp>
+        <p:nvSpPr>
+          <p:cNvPr id="14" name="Rectangle 13"/>
+          <p:cNvSpPr/>
+          <p:nvPr/>
+        </p:nvSpPr>
+        <p:spPr>
+          <a:xfrm>
+            <a:off x="585216" y="2962656"/>
+            <a:ext cx="64008" cy="658368"/>
+          </a:xfrm>
+          <a:prstGeom prst="rect">
+            <a:avLst/>
+          </a:prstGeom>
+          <a:solidFill>
+            <a:srgbClr val="ED1C24"/>
+          </a:solidFill>
+          <a:ln>
+            <a:noFill/>
+          </a:ln>
+          <a:effectLst/>
+        </p:spPr>
+        <p:style>
+          <a:lnRef idx="1">
+            <a:schemeClr val="accent1"/>
+          </a:lnRef>
+          <a:fillRef idx="3">
+            <a:schemeClr val="accent1"/>
+          </a:fillRef>
+          <a:effectRef idx="2">
+            <a:schemeClr val="accent1"/>
+          </a:effectRef>
+          <a:fontRef idx="minor">
+            <a:schemeClr val="lt1"/>
+          </a:fontRef>
+        </p:style>
+        <p:txBody>
+          <a:bodyPr rtlCol="0" anchor="ctr"/>
+          <a:lstStyle/>
+          <a:p>
+            <a:pPr algn="ctr"/>
+            <a:endParaRPr/>
+          </a:p>
+        </p:txBody>
+      </p:sp>
+      <p:sp>
+        <p:nvSpPr>
+          <p:cNvPr id="15" name="TextBox 14"/>
+          <p:cNvSpPr txBox="1"/>
+          <p:nvPr/>
+        </p:nvSpPr>
+        <p:spPr>
+          <a:xfrm>
+            <a:off x="859536" y="3163824"/>
+            <a:ext cx="3977639" cy="292608"/>
+          </a:xfrm>
+          <a:prstGeom prst="rect">
+            <a:avLst/>
+          </a:prstGeom>
+          <a:noFill/>
+        </p:spPr>
+        <p:txBody>
+          <a:bodyPr wrap="square" lIns="0" tIns="0" rIns="0" bIns="0">
+            <a:spAutoFit/>
+          </a:bodyPr>
+          <a:lstStyle/>
+          <a:p>
+            <a:pPr algn="l">
+              <a:spcBef>
+                <a:spcPts val="0"/>
+              </a:spcBef>
+              <a:spcAft>
+                <a:spcPts val="600"/>
+              </a:spcAft>
+            </a:pPr>
+            <a:r>
+              <a:rPr sz="1350" b="0">
+                <a:solidFill>
+                  <a:srgbClr val="FFFFFF"/>
+                </a:solidFill>
+                <a:latin typeface="Klavika Bold"/>
+              </a:rPr>
+              <a:t>Take it with you</a:t>
+            </a:r>
+          </a:p>
+        </p:txBody>
+      </p:sp>
+      <p:sp>
+        <p:nvSpPr>
+          <p:cNvPr id="16" name="TextBox 15"/>
+          <p:cNvSpPr txBox="1"/>
+          <p:nvPr/>
+        </p:nvSpPr>
+        <p:spPr>
+          <a:xfrm>
+            <a:off x="5065776" y="3163824"/>
+            <a:ext cx="6263640" cy="292608"/>
+          </a:xfrm>
+          <a:prstGeom prst="rect">
+            <a:avLst/>
+          </a:prstGeom>
+          <a:noFill/>
+        </p:spPr>
+        <p:txBody>
+          <a:bodyPr wrap="square" lIns="0" tIns="0" rIns="0" bIns="0">
+            <a:spAutoFit/>
+          </a:bodyPr>
+          <a:lstStyle/>
+          <a:p>
+            <a:pPr algn="l">
+              <a:spcBef>
+                <a:spcPts val="0"/>
+              </a:spcBef>
+              <a:spcAft>
+                <a:spcPts val="600"/>
+              </a:spcAft>
+            </a:pPr>
+            <a:r>
+              <a:rPr sz="1300" b="0">
+                <a:solidFill>
+                  <a:srgbClr val="D8DADE"/>
+                </a:solidFill>
+                <a:latin typeface="Klavika Regular"/>
+              </a:rPr>
+              <a:t>Export as GGUF (Q4_K_M) and run it in llama.cpp, LM Studio, Ollama or Lemonade. Compare answers and speed.</a:t>
+            </a:r>
+          </a:p>
+        </p:txBody>
+      </p:sp>
+    </p:spTree>
+  </p:cSld>
+  <p:clrMapOvr>
+    <a:masterClrMapping/>
+  </p:clrMapOvr>
+</p:sld>
+</file>
+
+<file path=ppt/slides/slide23.xml><?xml version="1.0" encoding="utf-8"?>
+<p:sld xmlns:a="http://schemas.openxmlformats.org/drawingml/2006/main" xmlns:p="http://schemas.openxmlformats.org/presentationml/2006/main" xmlns:r="http://schemas.openxmlformats.org/officeDocument/2006/relationships">
+  <p:cSld>
+    <p:bg>
+      <p:bgPr>
+        <a:blipFill rotWithShape="1">
+          <a:blip r:embed="rId2"/>
+          <a:stretch>
+            <a:fillRect/>
+          </a:stretch>
+        </a:blipFill>
+        <a:effectLst/>
+      </p:bgPr>
+    </p:bg>
+    <p:spTree>
+      <p:nvGrpSpPr>
+        <p:cNvPr id="1" name=""/>
+        <p:cNvGrpSpPr/>
+        <p:nvPr/>
+      </p:nvGrpSpPr>
+      <p:grpSpPr>
+        <a:xfrm>
+          <a:off x="0" y="0"/>
+          <a:ext cx="0" cy="0"/>
+          <a:chOff x="0" y="0"/>
+          <a:chExt cx="0" cy="0"/>
+        </a:xfrm>
+      </p:grpSpPr>
+      <p:sp>
+        <p:nvSpPr>
+          <p:cNvPr id="2" name="Title 1"/>
+          <p:cNvSpPr>
+            <a:spLocks noGrp="1"/>
+          </p:cNvSpPr>
+          <p:nvPr>
+            <p:ph type="title"/>
+          </p:nvPr>
+        </p:nvSpPr>
+        <p:spPr/>
+        <p:txBody>
+          <a:bodyPr/>
+          <a:lstStyle/>
+          <a:p>
+            <a:r>
+              <a:rPr sz="3200" b="0">
+                <a:solidFill>
+                  <a:srgbClr val="FFFFFF"/>
+                </a:solidFill>
+                <a:latin typeface="Klavika Bold"/>
+              </a:rPr>
+              <a:t>Teach it your own task</a:t>
+            </a:r>
+          </a:p>
+        </p:txBody>
+      </p:sp>
+      <p:sp>
+        <p:nvSpPr>
+          <p:cNvPr id="3" name="TextBox 2"/>
+          <p:cNvSpPr txBox="1"/>
+          <p:nvPr/>
+        </p:nvSpPr>
+        <p:spPr>
+          <a:xfrm>
+            <a:off x="585216" y="1280160"/>
+            <a:ext cx="11018520" cy="271613"/>
+          </a:xfrm>
+          <a:prstGeom prst="rect">
+            <a:avLst/>
+          </a:prstGeom>
+          <a:noFill/>
+        </p:spPr>
+        <p:txBody>
+          <a:bodyPr wrap="square" lIns="0" tIns="0" rIns="0" bIns="0">
+            <a:spAutoFit/>
+          </a:bodyPr>
+          <a:lstStyle/>
+          <a:p>
+            <a:pPr algn="l">
+              <a:spcBef>
+                <a:spcPts val="0"/>
+              </a:spcBef>
+              <a:spcAft>
+                <a:spcPts val="600"/>
+              </a:spcAft>
+            </a:pPr>
+            <a:r>
+              <a:rPr sz="1600" b="0" dirty="0">
+                <a:solidFill>
+                  <a:srgbClr val="D8DADE"/>
+                </a:solidFill>
+                <a:latin typeface="Klavika Regular"/>
+              </a:rPr>
+              <a:t>Any task with one right answer per input works the same way as today's tickets.</a:t>
+            </a:r>
+            <a:r>
+              <a:rPr lang="en-US" sz="1600" b="0" dirty="0">
+                <a:solidFill>
+                  <a:srgbClr val="D8DADE"/>
+                </a:solidFill>
+                <a:latin typeface="Klavika Regular"/>
+              </a:rPr>
+              <a:t/>
+            </a:r>
+            <a:r>
+              <a:rPr lang="en-US" dirty="0"/>
+              <a:t/>
+            </a:r>
+            <a:r>
+              <a:rPr sz="1600" b="0" dirty="0">
+                <a:solidFill>
+                  <a:srgbClr val="D8DADE"/>
+                </a:solidFill>
+                <a:latin typeface="Klavika Regular"/>
+              </a:rPr>
+              <a:t/>
+            </a:r>
+            <a:r>
+              <a:rPr lang="en-US" sz="1600" b="0" dirty="0">
+                <a:solidFill>
+                  <a:srgbClr val="D8DADE"/>
+                </a:solidFill>
+                <a:latin typeface="Klavika Regular"/>
+              </a:rPr>
+              <a:t/>
+            </a:r>
+            <a:r>
+              <a:rPr sz="1600" b="0" dirty="0">
+                <a:solidFill>
+                  <a:srgbClr val="D8DADE"/>
+                </a:solidFill>
+                <a:latin typeface="Klavika Regular"/>
+              </a:rPr>
+              <a:t/>
+            </a:r>
+          </a:p>
+        </p:txBody>
+      </p:sp>
+      <p:sp>
+        <p:nvSpPr>
+          <p:cNvPr id="4" name="Rectangle 3"/>
+          <p:cNvSpPr/>
+          <p:nvPr/>
+        </p:nvSpPr>
+        <p:spPr>
+          <a:xfrm>
+            <a:off x="585216" y="1874519"/>
+            <a:ext cx="5349240" cy="3246120"/>
+          </a:xfrm>
+          <a:prstGeom prst="rect">
+            <a:avLst/>
+          </a:prstGeom>
+          <a:solidFill>
+            <a:srgbClr val="1C1C1C"/>
+          </a:solidFill>
+          <a:ln w="9525">
+            <a:solidFill>
+              <a:srgbClr val="333333"/>
+            </a:solidFill>
+          </a:ln>
+          <a:effectLst/>
+        </p:spPr>
+        <p:style>
+          <a:lnRef idx="1">
+            <a:schemeClr val="accent1"/>
+          </a:lnRef>
+          <a:fillRef idx="3">
+            <a:schemeClr val="accent1"/>
+          </a:fillRef>
+          <a:effectRef idx="2">
+            <a:schemeClr val="accent1"/>
+          </a:effectRef>
+          <a:fontRef idx="minor">
+            <a:schemeClr val="lt1"/>
+          </a:fontRef>
+        </p:style>
+        <p:txBody>
+          <a:bodyPr rtlCol="0" anchor="ctr"/>
+          <a:lstStyle/>
+          <a:p>
+            <a:endParaRPr/>
+          </a:p>
+        </p:txBody>
+      </p:sp>
+      <p:sp>
+        <p:nvSpPr>
+          <p:cNvPr id="5" name="Rectangle 4"/>
+          <p:cNvSpPr/>
+          <p:nvPr/>
+        </p:nvSpPr>
+        <p:spPr>
+          <a:xfrm>
+            <a:off x="585216" y="1874519"/>
+            <a:ext cx="5349240" cy="64008"/>
+          </a:xfrm>
+          <a:prstGeom prst="rect">
+            <a:avLst/>
+          </a:prstGeom>
+          <a:solidFill>
+            <a:srgbClr val="F26522"/>
+          </a:solidFill>
+          <a:ln>
+            <a:noFill/>
+          </a:ln>
+          <a:effectLst/>
+        </p:spPr>
+        <p:style>
+          <a:lnRef idx="1">
+            <a:schemeClr val="accent1"/>
+          </a:lnRef>
+          <a:fillRef idx="3">
+            <a:schemeClr val="accent1"/>
+          </a:fillRef>
+          <a:effectRef idx="2">
+            <a:schemeClr val="accent1"/>
+          </a:effectRef>
+          <a:fontRef idx="minor">
+            <a:schemeClr val="lt1"/>
+          </a:fontRef>
+        </p:style>
+        <p:txBody>
+          <a:bodyPr rtlCol="0" anchor="ctr"/>
+          <a:lstStyle/>
+          <a:p>
+            <a:pPr algn="ctr"/>
+            <a:endParaRPr/>
+          </a:p>
+        </p:txBody>
+      </p:sp>
+      <p:sp>
+        <p:nvSpPr>
+          <p:cNvPr id="6" name="Rounded Rectangle 5"/>
+          <p:cNvSpPr/>
+          <p:nvPr/>
+        </p:nvSpPr>
+        <p:spPr>
+          <a:xfrm>
+            <a:off x="859536" y="2185415"/>
+            <a:ext cx="777240" cy="274320"/>
+          </a:xfrm>
+          <a:prstGeom prst="roundRect">
+            <a:avLst/>
+          </a:prstGeom>
+          <a:solidFill>
+            <a:srgbClr val="F26522"/>
+          </a:solidFill>
+          <a:ln>
+            <a:noFill/>
+          </a:ln>
+          <a:effectLst/>
+        </p:spPr>
+        <p:style>
+          <a:lnRef idx="1">
+            <a:schemeClr val="accent1"/>
+          </a:lnRef>
+          <a:fillRef idx="3">
+            <a:schemeClr val="accent1"/>
+          </a:fillRef>
+          <a:effectRef idx="2">
+            <a:schemeClr val="accent1"/>
+          </a:effectRef>
+          <a:fontRef idx="minor">
+            <a:schemeClr val="lt1"/>
+          </a:fontRef>
+        </p:style>
+        <p:txBody>
+          <a:bodyPr wrap="none" lIns="0" tIns="0" rIns="0" bIns="0" rtlCol="0" anchor="ctr"/>
+          <a:lstStyle/>
+          <a:p>
+            <a:pPr algn="ctr"/>
+            <a:r>
+              <a:rPr sz="1100">
+                <a:solidFill>
+                  <a:srgbClr val="FFFFFF"/>
+                </a:solidFill>
+                <a:latin typeface="Klavika Bold"/>
+              </a:rPr>
+              <a:t>IDEAS</a:t>
+            </a:r>
+          </a:p>
+        </p:txBody>
+      </p:sp>
+      <p:sp>
+        <p:nvSpPr>
+          <p:cNvPr id="7" name="TextBox 6"/>
+          <p:cNvSpPr txBox="1"/>
+          <p:nvPr/>
+        </p:nvSpPr>
+        <p:spPr>
+          <a:xfrm>
+            <a:off x="1755648" y="2221991"/>
+            <a:ext cx="3886200" cy="256032"/>
+          </a:xfrm>
+          <a:prstGeom prst="rect">
+            <a:avLst/>
+          </a:prstGeom>
+          <a:noFill/>
+        </p:spPr>
+        <p:txBody>
+          <a:bodyPr wrap="square" lIns="0" tIns="0" rIns="0" bIns="0">
+            <a:spAutoFit/>
+          </a:bodyPr>
+          <a:lstStyle/>
+          <a:p>
+            <a:pPr algn="l">
+              <a:spcBef>
+                <a:spcPts val="0"/>
+              </a:spcBef>
+              <a:spcAft>
+                <a:spcPts val="600"/>
+              </a:spcAft>
+            </a:pPr>
+            <a:r>
+              <a:rPr sz="1600" b="0">
+                <a:solidFill>
+                  <a:srgbClr val="FFFFFF"/>
+                </a:solidFill>
+                <a:latin typeface="Klavika Bold"/>
+              </a:rPr>
+              <a:t>Pick something small</a:t>
+            </a:r>
+          </a:p>
+        </p:txBody>
+      </p:sp>
+      <p:sp>
+        <p:nvSpPr>
+          <p:cNvPr id="8" name="TextBox 7"/>
+          <p:cNvSpPr txBox="1"/>
+          <p:nvPr/>
+        </p:nvSpPr>
+        <p:spPr>
+          <a:xfrm>
+            <a:off x="859536" y="2679191"/>
+            <a:ext cx="4800600" cy="914400"/>
+          </a:xfrm>
+          <a:prstGeom prst="rect">
+            <a:avLst/>
+          </a:prstGeom>
+          <a:noFill/>
+        </p:spPr>
+        <p:txBody>
+          <a:bodyPr wrap="square" lIns="0" tIns="0" rIns="0" bIns="0">
+            <a:spAutoFit/>
+          </a:bodyPr>
+          <a:lstStyle/>
+          <a:p>
+            <a:pPr>
+              <a:spcBef>
+                <a:spcPts val="0"/>
+              </a:spcBef>
+              <a:spcAft>
+                <a:spcPts val="800"/>
+              </a:spcAft>
+            </a:pPr>
+            <a:r>
+              <a:rPr sz="1350" dirty="0">
+                <a:solidFill>
+                  <a:srgbClr val="F26522"/>
+                </a:solidFill>
+                <a:latin typeface="Klavika Regular"/>
+              </a:rPr>
+              <a:t>•  </a:t>
+            </a:r>
+            <a:r>
+              <a:rPr sz="1350" dirty="0">
+                <a:solidFill>
+                  <a:srgbClr val="D8DADE"/>
+                </a:solidFill>
+                <a:latin typeface="Klavika Regular"/>
+              </a:rPr>
+              <a:t>One right answer per input, so you can check it</a:t>
+            </a:r>
+          </a:p>
+          <a:p>
+            <a:pPr>
+              <a:spcBef>
+                <a:spcPts val="0"/>
+              </a:spcBef>
+              <a:spcAft>
+                <a:spcPts val="800"/>
+              </a:spcAft>
+            </a:pPr>
+            <a:r>
+              <a:rPr sz="1350" dirty="0">
+                <a:solidFill>
+                  <a:srgbClr val="F26522"/>
+                </a:solidFill>
+                <a:latin typeface="Klavika Regular"/>
+              </a:rPr>
+              <a:t>•  </a:t>
+            </a:r>
+            <a:r>
+              <a:rPr sz="1350" dirty="0">
+                <a:solidFill>
+                  <a:srgbClr val="D8DADE"/>
+                </a:solidFill>
+                <a:latin typeface="Klavika Regular"/>
+              </a:rPr>
+              <a:t>A short, fixed output, like today's seven fields</a:t>
+            </a:r>
+          </a:p>
+        </p:txBody>
+      </p:sp>
+      <p:sp>
+        <p:nvSpPr>
+          <p:cNvPr id="9" name="Rectangle 8"/>
+          <p:cNvSpPr/>
+          <p:nvPr/>
+        </p:nvSpPr>
+        <p:spPr>
+          <a:xfrm>
+            <a:off x="859536" y="3630168"/>
+            <a:ext cx="4800600" cy="1234440"/>
+          </a:xfrm>
+          <a:prstGeom prst="rect">
+            <a:avLst/>
+          </a:prstGeom>
+          <a:solidFill>
+            <a:srgbClr val="101010"/>
+          </a:solidFill>
+          <a:ln w="9525">
+            <a:solidFill>
+              <a:srgbClr val="333333"/>
+            </a:solidFill>
+          </a:ln>
+          <a:effectLst/>
+        </p:spPr>
+        <p:style>
+          <a:lnRef idx="1">
+            <a:schemeClr val="accent1"/>
+          </a:lnRef>
+          <a:fillRef idx="3">
+            <a:schemeClr val="accent1"/>
+          </a:fillRef>
+          <a:effectRef idx="2">
+            <a:schemeClr val="accent1"/>
+          </a:effectRef>
+          <a:fontRef idx="minor">
+            <a:schemeClr val="lt1"/>
+          </a:fontRef>
+        </p:style>
+        <p:txBody>
+          <a:bodyPr rtlCol="0" anchor="ctr"/>
+          <a:lstStyle/>
+          <a:p>
+            <a:pPr algn="ctr"/>
+            <a:endParaRPr/>
+          </a:p>
+        </p:txBody>
+      </p:sp>
+      <p:sp>
+        <p:nvSpPr>
+          <p:cNvPr id="10" name="TextBox 9"/>
+          <p:cNvSpPr txBox="1"/>
+          <p:nvPr/>
+        </p:nvSpPr>
+        <p:spPr>
+          <a:xfrm>
+            <a:off x="1024127" y="3794759"/>
+            <a:ext cx="4471416" cy="941832"/>
+          </a:xfrm>
+          <a:prstGeom prst="rect">
+            <a:avLst/>
+          </a:prstGeom>
+          <a:noFill/>
+        </p:spPr>
+        <p:txBody>
+          <a:bodyPr wrap="square" lIns="0" tIns="0" rIns="0" bIns="0">
+            <a:spAutoFit/>
+          </a:bodyPr>
+          <a:lstStyle/>
+          <a:p>
+            <a:pPr algn="l">
+              <a:lnSpc>
+                <a:spcPct val="115000"/>
+              </a:lnSpc>
+              <a:spcBef>
+                <a:spcPts val="0"/>
+              </a:spcBef>
+              <a:spcAft>
+                <a:spcPts val="300"/>
+              </a:spcAft>
+            </a:pPr>
+            <a:r>
+              <a:rPr sz="1050" b="0" dirty="0">
+                <a:solidFill>
+                  <a:srgbClr val="C6C8CC"/>
+                </a:solidFill>
+                <a:latin typeface="Consolas"/>
+              </a:rPr>
+              <a:t>meeting notes  -&gt; {owner, task, due}</a:t>
+            </a:r>
+          </a:p>
+          <a:p>
+            <a:pPr algn="l">
+              <a:lnSpc>
+                <a:spcPct val="115000"/>
+              </a:lnSpc>
+              <a:spcBef>
+                <a:spcPts val="0"/>
+              </a:spcBef>
+              <a:spcAft>
+                <a:spcPts val="300"/>
+              </a:spcAft>
+            </a:pPr>
+            <a:r>
+              <a:rPr sz="1050" b="0" dirty="0">
+                <a:solidFill>
+                  <a:srgbClr val="C6C8CC"/>
+                </a:solidFill>
+                <a:latin typeface="Consolas"/>
+              </a:rPr>
+              <a:t>receipt text   -&gt; {merchant, date, total}</a:t>
+            </a:r>
+          </a:p>
+          <a:p>
+            <a:pPr algn="l">
+              <a:lnSpc>
+                <a:spcPct val="115000"/>
+              </a:lnSpc>
+              <a:spcBef>
+                <a:spcPts val="0"/>
+              </a:spcBef>
+              <a:spcAft>
+                <a:spcPts val="300"/>
+              </a:spcAft>
+            </a:pPr>
+            <a:r>
+              <a:rPr sz="1050" b="0" dirty="0">
+                <a:solidFill>
+                  <a:srgbClr val="C6C8CC"/>
+                </a:solidFill>
+                <a:latin typeface="Consolas"/>
+              </a:rPr>
+              <a:t>bug report     -&gt; {component, severity}</a:t>
+            </a:r>
+          </a:p>
+          <a:p>
+            <a:pPr algn="l">
+              <a:lnSpc>
+                <a:spcPct val="115000"/>
+              </a:lnSpc>
+              <a:spcBef>
+                <a:spcPts val="0"/>
+              </a:spcBef>
+              <a:spcAft>
+                <a:spcPts val="300"/>
+              </a:spcAft>
+            </a:pPr>
+            <a:r>
+              <a:rPr sz="1050" b="0" dirty="0">
+                <a:solidFill>
+                  <a:srgbClr val="C6C8CC"/>
+                </a:solidFill>
+                <a:latin typeface="Consolas"/>
+              </a:rPr>
+              <a:t>job ad         -&gt; {title, remote, salary}</a:t>
+            </a:r>
+          </a:p>
+          <a:p>
+            <a:pPr algn="l">
+              <a:lnSpc>
+                <a:spcPct val="115000"/>
+              </a:lnSpc>
+              <a:spcBef>
+                <a:spcPts val="0"/>
+              </a:spcBef>
+              <a:spcAft>
+                <a:spcPts val="300"/>
+              </a:spcAft>
+            </a:pPr>
+            <a:r>
+              <a:rPr sz="1050" b="0" dirty="0">
+                <a:solidFill>
+                  <a:srgbClr val="C6C8CC"/>
+                </a:solidFill>
+                <a:latin typeface="Consolas"/>
+              </a:rPr>
+              <a:t>casual email   -&gt; a polite, formal reply</a:t>
+            </a:r>
+          </a:p>
+        </p:txBody>
+      </p:sp>
+      <p:sp>
+        <p:nvSpPr>
+          <p:cNvPr id="11" name="Rectangle 10"/>
+          <p:cNvSpPr/>
+          <p:nvPr/>
+        </p:nvSpPr>
+        <p:spPr>
+          <a:xfrm>
+            <a:off x="6254496" y="1874519"/>
+            <a:ext cx="5349240" cy="3246120"/>
+          </a:xfrm>
+          <a:prstGeom prst="rect">
+            <a:avLst/>
+          </a:prstGeom>
+          <a:solidFill>
+            <a:srgbClr val="1C1C1C"/>
+          </a:solidFill>
+          <a:ln w="9525">
+            <a:solidFill>
+              <a:srgbClr val="333333"/>
+            </a:solidFill>
+          </a:ln>
+          <a:effectLst/>
+        </p:spPr>
+        <p:style>
+          <a:lnRef idx="1">
+            <a:schemeClr val="accent1"/>
+          </a:lnRef>
+          <a:fillRef idx="3">
+            <a:schemeClr val="accent1"/>
+          </a:fillRef>
+          <a:effectRef idx="2">
+            <a:schemeClr val="accent1"/>
+          </a:effectRef>
+          <a:fontRef idx="minor">
+            <a:schemeClr val="lt1"/>
+          </a:fontRef>
+        </p:style>
+        <p:txBody>
+          <a:bodyPr rtlCol="0" anchor="ctr"/>
+          <a:lstStyle/>
+          <a:p>
+            <a:endParaRPr/>
+          </a:p>
+        </p:txBody>
+      </p:sp>
+      <p:sp>
+        <p:nvSpPr>
+          <p:cNvPr id="12" name="Rectangle 11"/>
+          <p:cNvSpPr/>
+          <p:nvPr/>
+        </p:nvSpPr>
+        <p:spPr>
+          <a:xfrm>
+            <a:off x="6254496" y="1874519"/>
+            <a:ext cx="5349240" cy="64008"/>
+          </a:xfrm>
+          <a:prstGeom prst="rect">
+            <a:avLst/>
+          </a:prstGeom>
+          <a:solidFill>
+            <a:srgbClr val="007C97"/>
+          </a:solidFill>
+          <a:ln>
+            <a:noFill/>
+          </a:ln>
+          <a:effectLst/>
+        </p:spPr>
+        <p:style>
+          <a:lnRef idx="1">
+            <a:schemeClr val="accent1"/>
+          </a:lnRef>
+          <a:fillRef idx="3">
+            <a:schemeClr val="accent1"/>
+          </a:fillRef>
+          <a:effectRef idx="2">
+            <a:schemeClr val="accent1"/>
+          </a:effectRef>
+          <a:fontRef idx="minor">
+            <a:schemeClr val="lt1"/>
+          </a:fontRef>
+        </p:style>
+        <p:txBody>
+          <a:bodyPr rtlCol="0" anchor="ctr"/>
+          <a:lstStyle/>
+          <a:p>
+            <a:pPr algn="ctr"/>
+            <a:endParaRPr/>
+          </a:p>
+        </p:txBody>
+      </p:sp>
+      <p:sp>
+        <p:nvSpPr>
+          <p:cNvPr id="13" name="Rounded Rectangle 12"/>
+          <p:cNvSpPr/>
+          <p:nvPr/>
+        </p:nvSpPr>
+        <p:spPr>
+          <a:xfrm>
+            <a:off x="6528816" y="2185415"/>
+            <a:ext cx="960120" cy="274320"/>
+          </a:xfrm>
+          <a:prstGeom prst="roundRect">
+            <a:avLst/>
+          </a:prstGeom>
+          <a:solidFill>
+            <a:srgbClr val="007C97"/>
+          </a:solidFill>
+          <a:ln>
+            <a:noFill/>
+          </a:ln>
+          <a:effectLst/>
+        </p:spPr>
+        <p:style>
+          <a:lnRef idx="1">
+            <a:schemeClr val="accent1"/>
+          </a:lnRef>
+          <a:fillRef idx="3">
+            <a:schemeClr val="accent1"/>
+          </a:fillRef>
+          <a:effectRef idx="2">
+            <a:schemeClr val="accent1"/>
+          </a:effectRef>
+          <a:fontRef idx="minor">
+            <a:schemeClr val="lt1"/>
+          </a:fontRef>
+        </p:style>
+        <p:txBody>
+          <a:bodyPr wrap="none" lIns="0" tIns="0" rIns="0" bIns="0" rtlCol="0" anchor="ctr"/>
+          <a:lstStyle/>
+          <a:p>
+            <a:pPr algn="ctr"/>
+            <a:r>
+              <a:rPr sz="1100">
+                <a:solidFill>
+                  <a:srgbClr val="FFFFFF"/>
+                </a:solidFill>
+                <a:latin typeface="Klavika Bold"/>
+              </a:rPr>
+              <a:t>STEPS</a:t>
+            </a:r>
+          </a:p>
+        </p:txBody>
+      </p:sp>
+      <p:sp>
+        <p:nvSpPr>
+          <p:cNvPr id="14" name="TextBox 13"/>
+          <p:cNvSpPr txBox="1"/>
+          <p:nvPr/>
+        </p:nvSpPr>
+        <p:spPr>
+          <a:xfrm>
+            <a:off x="7607808" y="2221991"/>
+            <a:ext cx="3703320" cy="256032"/>
+          </a:xfrm>
+          <a:prstGeom prst="rect">
+            <a:avLst/>
+          </a:prstGeom>
+          <a:noFill/>
+        </p:spPr>
+        <p:txBody>
+          <a:bodyPr wrap="square" lIns="0" tIns="0" rIns="0" bIns="0">
+            <a:spAutoFit/>
+          </a:bodyPr>
+          <a:lstStyle/>
+          <a:p>
+            <a:pPr algn="l">
+              <a:spcBef>
+                <a:spcPts val="0"/>
+              </a:spcBef>
+              <a:spcAft>
+                <a:spcPts val="600"/>
+              </a:spcAft>
+            </a:pPr>
+            <a:r>
+              <a:rPr sz="1500" b="0">
+                <a:solidFill>
+                  <a:srgbClr val="FFFFFF"/>
+                </a:solidFill>
+                <a:latin typeface="Klavika Bold"/>
+              </a:rPr>
+              <a:t>Write a few, generate the rest</a:t>
+            </a:r>
+          </a:p>
+        </p:txBody>
+      </p:sp>
+      <p:sp>
+        <p:nvSpPr>
+          <p:cNvPr id="15" name="TextBox 14"/>
+          <p:cNvSpPr txBox="1"/>
+          <p:nvPr/>
+        </p:nvSpPr>
+        <p:spPr>
+          <a:xfrm>
+            <a:off x="6528816" y="2679191"/>
+            <a:ext cx="4800600" cy="914400"/>
+          </a:xfrm>
+          <a:prstGeom prst="rect">
+            <a:avLst/>
+          </a:prstGeom>
+          <a:noFill/>
+        </p:spPr>
+        <p:txBody>
+          <a:bodyPr wrap="square" lIns="0" tIns="0" rIns="0" bIns="0">
+            <a:spAutoFit/>
+          </a:bodyPr>
+          <a:lstStyle/>
+          <a:p>
+            <a:pPr>
+              <a:spcBef>
+                <a:spcPts val="0"/>
+              </a:spcBef>
+              <a:spcAft>
+                <a:spcPts val="800"/>
+              </a:spcAft>
+            </a:pPr>
+            <a:r>
+              <a:rPr sz="1350" dirty="0">
+                <a:solidFill>
+                  <a:srgbClr val="007C97"/>
+                </a:solidFill>
+                <a:latin typeface="Klavika Regular"/>
+              </a:rPr>
+              <a:t>•  </a:t>
+            </a:r>
+            <a:r>
+              <a:rPr sz="1350" dirty="0">
+                <a:solidFill>
+                  <a:srgbClr val="D8DADE"/>
+                </a:solidFill>
+                <a:latin typeface="Klavika Regular"/>
+              </a:rPr>
+              <a:t>Your hand-written examples set the format and the bar</a:t>
+            </a:r>
+          </a:p>
+          <a:p>
+            <a:pPr>
+              <a:spcBef>
+                <a:spcPts val="0"/>
+              </a:spcBef>
+              <a:spcAft>
+                <a:spcPts val="800"/>
+              </a:spcAft>
+            </a:pPr>
+            <a:r>
+              <a:rPr sz="1350" dirty="0">
+                <a:solidFill>
+                  <a:srgbClr val="007C97"/>
+                </a:solidFill>
+                <a:latin typeface="Klavika Regular"/>
+              </a:rPr>
+              <a:t>•  </a:t>
+            </a:r>
+            <a:r>
+              <a:rPr sz="1350" dirty="0">
+                <a:solidFill>
+                  <a:srgbClr val="D8DADE"/>
+                </a:solidFill>
+                <a:latin typeface="Klavika Regular"/>
+              </a:rPr>
+              <a:t>A bigger model adds variety: Qwen3.6-35B in Lemonade</a:t>
+            </a:r>
+          </a:p>
+        </p:txBody>
+      </p:sp>
+      <p:sp>
+        <p:nvSpPr>
+          <p:cNvPr id="16" name="Oval 15"/>
+          <p:cNvSpPr/>
+          <p:nvPr/>
+        </p:nvSpPr>
+        <p:spPr>
+          <a:xfrm>
+            <a:off x="6565392" y="3703320"/>
+            <a:ext cx="274320" cy="274320"/>
+          </a:xfrm>
+          <a:prstGeom prst="ellipse">
+            <a:avLst/>
+          </a:prstGeom>
+          <a:solidFill>
+            <a:srgbClr val="007C97"/>
+          </a:solidFill>
+          <a:ln>
+            <a:noFill/>
+          </a:ln>
+          <a:effectLst/>
+        </p:spPr>
+        <p:style>
+          <a:lnRef idx="1">
+            <a:schemeClr val="accent1"/>
+          </a:lnRef>
+          <a:fillRef idx="3">
+            <a:schemeClr val="accent1"/>
+          </a:fillRef>
+          <a:effectRef idx="2">
+            <a:schemeClr val="accent1"/>
+          </a:effectRef>
+          <a:fontRef idx="minor">
+            <a:schemeClr val="lt1"/>
+          </a:fontRef>
+        </p:style>
+        <p:txBody>
+          <a:bodyPr lIns="0" tIns="0" rIns="0" bIns="0" rtlCol="0" anchor="ctr"/>
+          <a:lstStyle/>
+          <a:p>
+            <a:pPr algn="ctr"/>
+            <a:r>
+              <a:rPr sz="1100">
+                <a:solidFill>
+                  <a:srgbClr val="FFFFFF"/>
+                </a:solidFill>
+                <a:latin typeface="Klavika Bold"/>
+              </a:rPr>
+              <a:t>1</a:t>
+            </a:r>
+          </a:p>
+        </p:txBody>
+      </p:sp>
+      <p:sp>
+        <p:nvSpPr>
+          <p:cNvPr id="17" name="TextBox 16"/>
+          <p:cNvSpPr txBox="1"/>
+          <p:nvPr/>
+        </p:nvSpPr>
+        <p:spPr>
+          <a:xfrm>
+            <a:off x="6967728" y="3721607"/>
+            <a:ext cx="4343400" cy="274320"/>
+          </a:xfrm>
+          <a:prstGeom prst="rect">
+            <a:avLst/>
+          </a:prstGeom>
+          <a:noFill/>
+        </p:spPr>
+        <p:txBody>
+          <a:bodyPr wrap="square" lIns="0" tIns="0" rIns="0" bIns="0">
+            <a:spAutoFit/>
+          </a:bodyPr>
+          <a:lstStyle/>
+          <a:p>
+            <a:pPr algn="l">
+              <a:spcBef>
+                <a:spcPts val="0"/>
+              </a:spcBef>
+              <a:spcAft>
+                <a:spcPts val="600"/>
+              </a:spcAft>
+            </a:pPr>
+            <a:r>
+              <a:rPr sz="1250" b="1" dirty="0">
+                <a:solidFill>
+                  <a:srgbClr val="FFFFFF"/>
+                </a:solidFill>
+                <a:latin typeface="Klavika Bold"/>
+              </a:rPr>
+              <a:t>Write  </a:t>
+            </a:r>
+            <a:r>
+              <a:rPr sz="1250" b="0" dirty="0">
+                <a:solidFill>
+                  <a:srgbClr val="D8DADE"/>
+                </a:solidFill>
+                <a:latin typeface="Klavika Regular"/>
+              </a:rPr>
+              <a:t>5 examples by hand, covering the cases you care about</a:t>
+            </a:r>
+          </a:p>
+        </p:txBody>
+      </p:sp>
+      <p:sp>
+        <p:nvSpPr>
+          <p:cNvPr id="18" name="Oval 17"/>
+          <p:cNvSpPr/>
+          <p:nvPr/>
+        </p:nvSpPr>
+        <p:spPr>
+          <a:xfrm>
+            <a:off x="6565392" y="4087368"/>
+            <a:ext cx="274320" cy="274320"/>
+          </a:xfrm>
+          <a:prstGeom prst="ellipse">
+            <a:avLst/>
+          </a:prstGeom>
+          <a:solidFill>
+            <a:srgbClr val="007C97"/>
+          </a:solidFill>
+          <a:ln>
+            <a:noFill/>
+          </a:ln>
+          <a:effectLst/>
+        </p:spPr>
+        <p:style>
+          <a:lnRef idx="1">
+            <a:schemeClr val="accent1"/>
+          </a:lnRef>
+          <a:fillRef idx="3">
+            <a:schemeClr val="accent1"/>
+          </a:fillRef>
+          <a:effectRef idx="2">
+            <a:schemeClr val="accent1"/>
+          </a:effectRef>
+          <a:fontRef idx="minor">
+            <a:schemeClr val="lt1"/>
+          </a:fontRef>
+        </p:style>
+        <p:txBody>
+          <a:bodyPr lIns="0" tIns="0" rIns="0" bIns="0" rtlCol="0" anchor="ctr"/>
+          <a:lstStyle/>
+          <a:p>
+            <a:pPr algn="ctr"/>
+            <a:r>
+              <a:rPr sz="1100">
+                <a:solidFill>
+                  <a:srgbClr val="FFFFFF"/>
+                </a:solidFill>
+                <a:latin typeface="Klavika Bold"/>
+              </a:rPr>
+              <a:t>2</a:t>
+            </a:r>
+          </a:p>
+        </p:txBody>
+      </p:sp>
+      <p:sp>
+        <p:nvSpPr>
+          <p:cNvPr id="19" name="TextBox 18"/>
+          <p:cNvSpPr txBox="1"/>
+          <p:nvPr/>
+        </p:nvSpPr>
+        <p:spPr>
+          <a:xfrm>
+            <a:off x="6967728" y="4105655"/>
+            <a:ext cx="4343400" cy="274320"/>
+          </a:xfrm>
+          <a:prstGeom prst="rect">
+            <a:avLst/>
+          </a:prstGeom>
+          <a:noFill/>
+        </p:spPr>
+        <p:txBody>
+          <a:bodyPr wrap="square" lIns="0" tIns="0" rIns="0" bIns="0">
+            <a:spAutoFit/>
+          </a:bodyPr>
+          <a:lstStyle/>
+          <a:p>
+            <a:pPr algn="l">
+              <a:spcBef>
+                <a:spcPts val="0"/>
+              </a:spcBef>
+              <a:spcAft>
+                <a:spcPts val="600"/>
+              </a:spcAft>
+            </a:pPr>
+            <a:r>
+              <a:rPr sz="1250" b="1">
+                <a:solidFill>
+                  <a:srgbClr val="FFFFFF"/>
+                </a:solidFill>
+                <a:latin typeface="Klavika Bold"/>
+              </a:rPr>
+              <a:t>Generate  </a:t>
+            </a:r>
+            <a:r>
+              <a:rPr sz="1250" b="0">
+                <a:solidFill>
+                  <a:srgbClr val="D8DADE"/>
+                </a:solidFill>
+                <a:latin typeface="Klavika Regular"/>
+              </a:rPr>
+              <a:t>50 more: paste yours and ask for more like them</a:t>
+            </a:r>
+          </a:p>
+        </p:txBody>
+      </p:sp>
+      <p:sp>
+        <p:nvSpPr>
+          <p:cNvPr id="20" name="Oval 19"/>
+          <p:cNvSpPr/>
+          <p:nvPr/>
+        </p:nvSpPr>
+        <p:spPr>
+          <a:xfrm>
+            <a:off x="6565392" y="4471416"/>
+            <a:ext cx="274320" cy="274320"/>
+          </a:xfrm>
+          <a:prstGeom prst="ellipse">
+            <a:avLst/>
+          </a:prstGeom>
+          <a:solidFill>
+            <a:srgbClr val="007C97"/>
+          </a:solidFill>
+          <a:ln>
+            <a:noFill/>
+          </a:ln>
+          <a:effectLst/>
+        </p:spPr>
+        <p:style>
+          <a:lnRef idx="1">
+            <a:schemeClr val="accent1"/>
+          </a:lnRef>
+          <a:fillRef idx="3">
+            <a:schemeClr val="accent1"/>
+          </a:fillRef>
+          <a:effectRef idx="2">
+            <a:schemeClr val="accent1"/>
+          </a:effectRef>
+          <a:fontRef idx="minor">
+            <a:schemeClr val="lt1"/>
+          </a:fontRef>
+        </p:style>
+        <p:txBody>
+          <a:bodyPr lIns="0" tIns="0" rIns="0" bIns="0" rtlCol="0" anchor="ctr"/>
+          <a:lstStyle/>
+          <a:p>
+            <a:pPr algn="ctr"/>
+            <a:r>
+              <a:rPr sz="1100">
+                <a:solidFill>
+                  <a:srgbClr val="FFFFFF"/>
+                </a:solidFill>
+                <a:latin typeface="Klavika Bold"/>
+              </a:rPr>
+              <a:t>3</a:t>
+            </a:r>
+          </a:p>
+        </p:txBody>
+      </p:sp>
+      <p:sp>
+        <p:nvSpPr>
+          <p:cNvPr id="21" name="TextBox 20"/>
+          <p:cNvSpPr txBox="1"/>
+          <p:nvPr/>
+        </p:nvSpPr>
+        <p:spPr>
+          <a:xfrm>
+            <a:off x="6967728" y="4489703"/>
+            <a:ext cx="4343400" cy="274320"/>
+          </a:xfrm>
+          <a:prstGeom prst="rect">
+            <a:avLst/>
+          </a:prstGeom>
+          <a:noFill/>
+        </p:spPr>
+        <p:txBody>
+          <a:bodyPr wrap="square" lIns="0" tIns="0" rIns="0" bIns="0">
+            <a:spAutoFit/>
+          </a:bodyPr>
+          <a:lstStyle/>
+          <a:p>
+            <a:pPr algn="l">
+              <a:spcBef>
+                <a:spcPts val="0"/>
+              </a:spcBef>
+              <a:spcAft>
+                <a:spcPts val="600"/>
+              </a:spcAft>
+            </a:pPr>
+            <a:r>
+              <a:rPr sz="1250" b="1">
+                <a:solidFill>
+                  <a:srgbClr val="FFFFFF"/>
+                </a:solidFill>
+                <a:latin typeface="Klavika Bold"/>
+              </a:rPr>
+              <a:t>Check  </a:t>
+            </a:r>
+            <a:r>
+              <a:rPr sz="1250" b="0">
+                <a:solidFill>
+                  <a:srgbClr val="D8DADE"/>
+                </a:solidFill>
+                <a:latin typeface="Klavika Regular"/>
+              </a:rPr>
+              <a:t>each one, keep 10 back for testing, train 30 steps</a:t>
+            </a:r>
+          </a:p>
+        </p:txBody>
+      </p:sp>
+    </p:spTree>
+  </p:cSld>
+  <p:clrMapOvr>
+    <a:masterClrMapping/>
+  </p:clrMapOvr>
+</p:sld>
+</file>
+
 <file path=ppt/slides/slide3.xml><?xml version="1.0" encoding="utf-8"?>
 <p:sld xmlns:a="http://schemas.openxmlformats.org/drawingml/2006/main" xmlns:r="http://schemas.openxmlformats.org/officeDocument/2006/relationships" xmlns:p="http://schemas.openxmlformats.org/presentationml/2006/main">
   <p:cSld>
@@ -32319,7 +36669,7 @@
                 </a:solidFill>
                 <a:latin typeface="Klavika Bold"/>
               </a:rPr>
-              <a:t>~0.1%</a:t>
+              <a:t>~1%</a:t>
             </a:r>
           </a:p>
         </p:txBody>
@@ -32361,7 +36711,7 @@
                 </a:solidFill>
                 <a:latin typeface="Klavika Regular"/>
               </a:rPr>
-              <a:t>of parameters trained</a:t>
+              <a:t>of weights trained today (23M)</a:t>
             </a:r>
           </a:p>
         </p:txBody>
@@ -33213,7 +37563,7 @@
                 </a:solidFill>
                 <a:latin typeface="Consolas"/>
               </a:rPr>
-              <a:t>{"instruction": "Summarize in one line.",</a:t>
+              <a:t>{"messages": [</a:t>
             </a:r>
           </a:p>
           <a:p>
@@ -33235,7 +37585,7 @@
                 </a:solidFill>
                 <a:latin typeface="Consolas"/>
               </a:rPr>
-              <a:t>  "input":  "&lt;article text&gt;",</a:t>
+              <a:t>  {"role": "user", "content": "&lt;support message&gt;"},</a:t>
             </a:r>
           </a:p>
           <a:p>
@@ -33257,7 +37607,7 @@
                 </a:solidFill>
                 <a:latin typeface="Consolas"/>
               </a:rPr>
-              <a:t>  "output": "&lt;summary&gt;"}</a:t>
+              <a:t>  {"role": "assistant", "content": "&lt;ticket JSON&gt;"}]}</a:t>
             </a:r>
           </a:p>
         </p:txBody>

</xml_diff>